<commit_message>
Rewrite Sub-CPMK 1.1–1.2 PPTs in more human, student-friendly language.
Replace machine-like jargon with everyday examples, reflective prompts,
and implementable classroom activities for beginner Digital Business students.

Co-authored-by: yusepa165-hue <yusepa165-hue@users.noreply.github.com>
</commit_message>
<xml_diff>
--- a/materi-technopreneurship/ppt/PPT01_SubCPMK_1_1_Entrepreneur_Technopreneur_Bisnis_Digital.pptx
+++ b/materi-technopreneurship/ppt/PPT01_SubCPMK_1_1_Entrepreneur_Technopreneur_Bisnis_Digital.pptx
@@ -3242,7 +3242,7 @@
         </p:nvSpPr>
         <p:spPr>
           <a:xfrm>
-            <a:off x="731520" y="1371600"/>
+            <a:off x="731520" y="1280160"/>
             <a:ext cx="10515600" cy="365760"/>
           </a:xfrm>
           <a:prstGeom prst="rect">
@@ -3258,13 +3258,13 @@
           <a:p>
             <a:pPr algn="l"/>
             <a:r>
-              <a:rPr sz="1600" b="1">
+              <a:rPr sz="1500" b="1">
                 <a:solidFill>
                   <a:srgbClr val="D97B2A"/>
                 </a:solidFill>
                 <a:latin typeface="Calibri"/>
               </a:rPr>
-              <a:t>MATA KULIAH TECHNOPRENEURSHIP</a:t>
+              <a:t>TECHNOPRENEURSHIP — PERTEMUAN AWAL</a:t>
             </a:r>
           </a:p>
         </p:txBody>
@@ -3277,8 +3277,8 @@
         </p:nvSpPr>
         <p:spPr>
           <a:xfrm>
-            <a:off x="731520" y="1920240"/>
-            <a:ext cx="10515600" cy="1280160"/>
+            <a:off x="731520" y="1828800"/>
+            <a:ext cx="10515600" cy="1371600"/>
           </a:xfrm>
           <a:prstGeom prst="rect">
             <a:avLst/>
@@ -3293,14 +3293,14 @@
           <a:p>
             <a:pPr algn="l"/>
             <a:r>
-              <a:rPr sz="3600" b="1">
+              <a:rPr sz="3200" b="1">
                 <a:solidFill>
                   <a:srgbClr val="FFFFFF"/>
                 </a:solidFill>
                 <a:latin typeface="Calibri"/>
               </a:rPr>
-              <a:t>Membedakan Entrepreneur,
-Technopreneur, dan Bisnis Digital</a:t>
+              <a:t>Mengenal Siapa Entrepreneur,
+Technopreneur, dan Pelaku Bisnis Digital</a:t>
             </a:r>
           </a:p>
         </p:txBody>
@@ -3313,8 +3313,8 @@
         </p:nvSpPr>
         <p:spPr>
           <a:xfrm>
-            <a:off x="731520" y="4114800"/>
-            <a:ext cx="10515600" cy="365760"/>
+            <a:off x="731520" y="4023360"/>
+            <a:ext cx="10515600" cy="457200"/>
           </a:xfrm>
           <a:prstGeom prst="rect">
             <a:avLst/>
@@ -3329,13 +3329,13 @@
           <a:p>
             <a:pPr algn="l"/>
             <a:r>
-              <a:rPr sz="1800" b="0">
+              <a:rPr sz="1700" b="0">
                 <a:solidFill>
                   <a:srgbClr val="E6EEF2"/>
                 </a:solidFill>
                 <a:latin typeface="Calibri"/>
               </a:rPr>
-              <a:t>Presentasi 1 · Sub-CPMK 1.1 · Level Dasar</a:t>
+              <a:t>Bahasa sederhana · Siap dipraktikkan · Untuk mahasiswa baru</a:t>
             </a:r>
           </a:p>
         </p:txBody>
@@ -3349,7 +3349,7 @@
         <p:spPr>
           <a:xfrm>
             <a:off x="731520" y="5669280"/>
-            <a:ext cx="10515600" cy="731520"/>
+            <a:ext cx="10515600" cy="640080"/>
           </a:xfrm>
           <a:prstGeom prst="rect">
             <a:avLst/>
@@ -3370,8 +3370,7 @@
                 </a:solidFill>
                 <a:latin typeface="Calibri"/>
               </a:rPr>
-              <a:t>S1 Bisnis Digital — Semester 3
-Referensi poros: Sulistyandari (Penerbit Adab)</a:t>
+              <a:t>S1 Bisnis Digital Semester 3 · Sub-CPMK 1.1</a:t>
             </a:r>
           </a:p>
         </p:txBody>
@@ -3504,13 +3503,13 @@
           <a:p>
             <a:pPr algn="l"/>
             <a:r>
-              <a:rPr sz="2800" b="1">
+              <a:rPr sz="2600" b="1">
                 <a:solidFill>
                   <a:srgbClr val="0F2C4C"/>
                 </a:solidFill>
                 <a:latin typeface="Calibri"/>
               </a:rPr>
-              <a:t>Bagaimana ketiga konsep saling terkait?</a:t>
+              <a:t>Ketiganya saling berhubungan</a:t>
             </a:r>
           </a:p>
         </p:txBody>
@@ -3545,7 +3544,7 @@
                 </a:solidFill>
                 <a:latin typeface="Calibri"/>
               </a:rPr>
-              <a:t>Jangan dipandang sebagai tiga dunia terpisah</a:t>
+              <a:t>Jangan anggap tiga dunia yang terpisah</a:t>
             </a:r>
           </a:p>
         </p:txBody>
@@ -3558,8 +3557,8 @@
         </p:nvSpPr>
         <p:spPr>
           <a:xfrm>
-            <a:off x="1371600" y="1554480"/>
-            <a:ext cx="9418320" cy="4114800"/>
+            <a:off x="1188720" y="1554480"/>
+            <a:ext cx="9784080" cy="4114800"/>
           </a:xfrm>
           <a:prstGeom prst="roundRect">
             <a:avLst/>
@@ -3601,8 +3600,8 @@
         </p:nvSpPr>
         <p:spPr>
           <a:xfrm>
-            <a:off x="1828800" y="1920240"/>
-            <a:ext cx="8503920" cy="457200"/>
+            <a:off x="1645920" y="2011680"/>
+            <a:ext cx="8869680" cy="457200"/>
           </a:xfrm>
           <a:prstGeom prst="rect">
             <a:avLst/>
@@ -3617,13 +3616,13 @@
           <a:p>
             <a:pPr algn="ctr"/>
             <a:r>
-              <a:rPr sz="1800" b="0">
+              <a:rPr sz="1700" b="0">
                 <a:solidFill>
                   <a:srgbClr val="5A6570"/>
                 </a:solidFill>
                 <a:latin typeface="Calibri"/>
               </a:rPr>
-              <a:t>Di kelas ini kita berlatih menjadi:</a:t>
+              <a:t>Di kelas ini, kita berlatih menjadi:</a:t>
             </a:r>
           </a:p>
         </p:txBody>
@@ -3636,8 +3635,8 @@
         </p:nvSpPr>
         <p:spPr>
           <a:xfrm>
-            <a:off x="1828800" y="2560320"/>
-            <a:ext cx="8503920" cy="731520"/>
+            <a:off x="1645920" y="2651760"/>
+            <a:ext cx="8869680" cy="731520"/>
           </a:xfrm>
           <a:prstGeom prst="rect">
             <a:avLst/>
@@ -3652,13 +3651,13 @@
           <a:p>
             <a:pPr algn="ctr"/>
             <a:r>
-              <a:rPr sz="2800" b="1">
+              <a:rPr sz="2600" b="1">
                 <a:solidFill>
                   <a:srgbClr val="0F2C4C"/>
                 </a:solidFill>
                 <a:latin typeface="Calibri"/>
               </a:rPr>
-              <a:t>Technopreneur di ranah Bisnis Digital</a:t>
+              <a:t>Technopreneur di dunia bisnis digital</a:t>
             </a:r>
           </a:p>
         </p:txBody>
@@ -3671,7 +3670,7 @@
         </p:nvSpPr>
         <p:spPr>
           <a:xfrm>
-            <a:off x="2103120" y="3566160"/>
+            <a:off x="2194560" y="3657600"/>
             <a:ext cx="7955279" cy="1645920"/>
           </a:xfrm>
           <a:prstGeom prst="rect">
@@ -3697,7 +3696,7 @@
                 </a:solidFill>
                 <a:latin typeface="Calibri"/>
               </a:rPr>
-              <a:t>• Pola pikir entrepreneur: lihat masalah &amp; peluang</a:t>
+              <a:t>• Hati entrepreneur: peduli pada masalah orang</a:t>
             </a:r>
           </a:p>
           <a:p>
@@ -3713,7 +3712,7 @@
                 </a:solidFill>
                 <a:latin typeface="Calibri"/>
               </a:rPr>
-              <a:t>• Cara technopreneur: teknologinya inti solusi</a:t>
+              <a:t>• Cara technopreneur: teknologi jadi jantung solusi</a:t>
             </a:r>
           </a:p>
           <a:p>
@@ -3729,7 +3728,7 @@
                 </a:solidFill>
                 <a:latin typeface="Calibri"/>
               </a:rPr>
-              <a:t>• Arena bisnis digital: pelanggan, kanal, dan monetisasi digital</a:t>
+              <a:t>• Arena bisnis digital: bertemu &amp; bertransaksi secara online</a:t>
             </a:r>
           </a:p>
         </p:txBody>
@@ -3764,7 +3763,7 @@
                 </a:solidFill>
                 <a:latin typeface="Calibri"/>
               </a:rPr>
-              <a:t>Technopreneurship · S1 Bisnis Digital Sem 3 · Sub-CPMK 1.1</a:t>
+              <a:t>Technopreneurship · Bisnis Digital Sem 3 · Sub-CPMK 1.1</a:t>
             </a:r>
           </a:p>
         </p:txBody>
@@ -3932,13 +3931,13 @@
           <a:p>
             <a:pPr algn="l"/>
             <a:r>
-              <a:rPr sz="2800" b="1">
+              <a:rPr sz="2600" b="1">
                 <a:solidFill>
                   <a:srgbClr val="0F2C4C"/>
                 </a:solidFill>
                 <a:latin typeface="Calibri"/>
               </a:rPr>
-              <a:t>Tabel pembeda cepat</a:t>
+              <a:t>Tabel pembeda yang bisa Anda pakai</a:t>
             </a:r>
           </a:p>
         </p:txBody>
@@ -3973,7 +3972,7 @@
                 </a:solidFill>
                 <a:latin typeface="Calibri"/>
               </a:rPr>
-              <a:t>Pakai ini saat menilai sebuah usaha</a:t>
+              <a:t>Simpan ini di catatan HP</a:t>
             </a:r>
           </a:p>
         </p:txBody>
@@ -4029,8 +4028,8 @@
         </p:nvSpPr>
         <p:spPr>
           <a:xfrm>
-            <a:off x="640080" y="1508760"/>
-            <a:ext cx="1874520" cy="411480"/>
+            <a:off x="621792" y="1508760"/>
+            <a:ext cx="2651760" cy="411480"/>
           </a:xfrm>
           <a:prstGeom prst="rect">
             <a:avLst/>
@@ -4045,13 +4044,13 @@
           <a:p>
             <a:pPr algn="l"/>
             <a:r>
-              <a:rPr sz="1400" b="1">
+              <a:rPr sz="1300" b="1">
                 <a:solidFill>
                   <a:srgbClr val="FFFFFF"/>
                 </a:solidFill>
                 <a:latin typeface="Calibri"/>
               </a:rPr>
-              <a:t>Aspek</a:t>
+              <a:t>Pertanyaan</a:t>
             </a:r>
           </a:p>
         </p:txBody>
@@ -4064,8 +4063,8 @@
         </p:nvSpPr>
         <p:spPr>
           <a:xfrm>
-            <a:off x="2651760" y="1508760"/>
-            <a:ext cx="2788920" cy="411480"/>
+            <a:off x="3364992" y="1508760"/>
+            <a:ext cx="2560320" cy="411480"/>
           </a:xfrm>
           <a:prstGeom prst="rect">
             <a:avLst/>
@@ -4080,13 +4079,13 @@
           <a:p>
             <a:pPr algn="l"/>
             <a:r>
-              <a:rPr sz="1400" b="1">
+              <a:rPr sz="1300" b="1">
                 <a:solidFill>
                   <a:srgbClr val="FFFFFF"/>
                 </a:solidFill>
                 <a:latin typeface="Calibri"/>
               </a:rPr>
-              <a:t>Entrepreneur umum</a:t>
+              <a:t>Entrepreneur</a:t>
             </a:r>
           </a:p>
         </p:txBody>
@@ -4099,8 +4098,8 @@
         </p:nvSpPr>
         <p:spPr>
           <a:xfrm>
-            <a:off x="5577840" y="1508760"/>
-            <a:ext cx="2788920" cy="411480"/>
+            <a:off x="6016752" y="1508760"/>
+            <a:ext cx="2651760" cy="411480"/>
           </a:xfrm>
           <a:prstGeom prst="rect">
             <a:avLst/>
@@ -4115,7 +4114,7 @@
           <a:p>
             <a:pPr algn="l"/>
             <a:r>
-              <a:rPr sz="1400" b="1">
+              <a:rPr sz="1300" b="1">
                 <a:solidFill>
                   <a:srgbClr val="FFFFFF"/>
                 </a:solidFill>
@@ -4134,8 +4133,8 @@
         </p:nvSpPr>
         <p:spPr>
           <a:xfrm>
-            <a:off x="8503919" y="1508760"/>
-            <a:ext cx="2880360" cy="411480"/>
+            <a:off x="8759952" y="1508760"/>
+            <a:ext cx="2651760" cy="411480"/>
           </a:xfrm>
           <a:prstGeom prst="rect">
             <a:avLst/>
@@ -4150,13 +4149,13 @@
           <a:p>
             <a:pPr algn="l"/>
             <a:r>
-              <a:rPr sz="1400" b="1">
+              <a:rPr sz="1300" b="1">
                 <a:solidFill>
                   <a:srgbClr val="FFFFFF"/>
                 </a:solidFill>
                 <a:latin typeface="Calibri"/>
               </a:rPr>
-              <a:t>Pelaku bisnis digital</a:t>
+              <a:t>Bisnis digital</a:t>
             </a:r>
           </a:p>
         </p:txBody>
@@ -4212,8 +4211,8 @@
         </p:nvSpPr>
         <p:spPr>
           <a:xfrm>
-            <a:off x="640080" y="2377439"/>
-            <a:ext cx="1874520" cy="548640"/>
+            <a:off x="621792" y="2331720"/>
+            <a:ext cx="2651760" cy="640080"/>
           </a:xfrm>
           <a:prstGeom prst="rect">
             <a:avLst/>
@@ -4228,13 +4227,13 @@
           <a:p>
             <a:pPr algn="l"/>
             <a:r>
-              <a:rPr sz="1400" b="1">
+              <a:rPr sz="1300" b="1">
                 <a:solidFill>
                   <a:srgbClr val="0F2C4C"/>
                 </a:solidFill>
                 <a:latin typeface="Calibri"/>
               </a:rPr>
-              <a:t>Inti nilai</a:t>
+              <a:t>Apa yang dijual?</a:t>
             </a:r>
           </a:p>
         </p:txBody>
@@ -4247,8 +4246,8 @@
         </p:nvSpPr>
         <p:spPr>
           <a:xfrm>
-            <a:off x="2651760" y="2377439"/>
-            <a:ext cx="2788920" cy="548640"/>
+            <a:off x="3364992" y="2331720"/>
+            <a:ext cx="2560320" cy="640080"/>
           </a:xfrm>
           <a:prstGeom prst="rect">
             <a:avLst/>
@@ -4263,7 +4262,7 @@
           <a:p>
             <a:pPr algn="l"/>
             <a:r>
-              <a:rPr sz="1400" b="0">
+              <a:rPr sz="1300" b="0">
                 <a:solidFill>
                   <a:srgbClr val="1C1C1C"/>
                 </a:solidFill>
@@ -4282,8 +4281,8 @@
         </p:nvSpPr>
         <p:spPr>
           <a:xfrm>
-            <a:off x="5577840" y="2377439"/>
-            <a:ext cx="2788920" cy="548640"/>
+            <a:off x="6016752" y="2331720"/>
+            <a:ext cx="2651760" cy="640080"/>
           </a:xfrm>
           <a:prstGeom prst="rect">
             <a:avLst/>
@@ -4298,13 +4297,13 @@
           <a:p>
             <a:pPr algn="l"/>
             <a:r>
-              <a:rPr sz="1400" b="0">
+              <a:rPr sz="1300" b="0">
                 <a:solidFill>
                   <a:srgbClr val="1C1C1C"/>
                 </a:solidFill>
                 <a:latin typeface="Calibri"/>
               </a:rPr>
-              <a:t>Solusi berbasis teknologi</a:t>
+              <a:t>Solusi yang hinggap di teknologi</a:t>
             </a:r>
           </a:p>
         </p:txBody>
@@ -4317,8 +4316,8 @@
         </p:nvSpPr>
         <p:spPr>
           <a:xfrm>
-            <a:off x="8503919" y="2377439"/>
-            <a:ext cx="2880360" cy="548640"/>
+            <a:off x="8759952" y="2331720"/>
+            <a:ext cx="2651760" cy="640080"/>
           </a:xfrm>
           <a:prstGeom prst="rect">
             <a:avLst/>
@@ -4333,13 +4332,13 @@
           <a:p>
             <a:pPr algn="l"/>
             <a:r>
-              <a:rPr sz="1400" b="0">
+              <a:rPr sz="1300" b="0">
                 <a:solidFill>
                   <a:srgbClr val="1C1C1C"/>
                 </a:solidFill>
                 <a:latin typeface="Calibri"/>
               </a:rPr>
-              <a:t>Nilai lewat ruang digital</a:t>
+              <a:t>Nilai yang hidup di online</a:t>
             </a:r>
           </a:p>
         </p:txBody>
@@ -4395,8 +4394,8 @@
         </p:nvSpPr>
         <p:spPr>
           <a:xfrm>
-            <a:off x="640080" y="3474720"/>
-            <a:ext cx="1874520" cy="548640"/>
+            <a:off x="621792" y="3429000"/>
+            <a:ext cx="2651760" cy="640080"/>
           </a:xfrm>
           <a:prstGeom prst="rect">
             <a:avLst/>
@@ -4411,13 +4410,13 @@
           <a:p>
             <a:pPr algn="l"/>
             <a:r>
-              <a:rPr sz="1400" b="1">
+              <a:rPr sz="1300" b="1">
                 <a:solidFill>
                   <a:srgbClr val="0F2C4C"/>
                 </a:solidFill>
                 <a:latin typeface="Calibri"/>
               </a:rPr>
-              <a:t>Peran teknologi</a:t>
+              <a:t>Teknologi di mana?</a:t>
             </a:r>
           </a:p>
         </p:txBody>
@@ -4430,8 +4429,8 @@
         </p:nvSpPr>
         <p:spPr>
           <a:xfrm>
-            <a:off x="2651760" y="3474720"/>
-            <a:ext cx="2788920" cy="548640"/>
+            <a:off x="3364992" y="3429000"/>
+            <a:ext cx="2560320" cy="640080"/>
           </a:xfrm>
           <a:prstGeom prst="rect">
             <a:avLst/>
@@ -4446,7 +4445,7 @@
           <a:p>
             <a:pPr algn="l"/>
             <a:r>
-              <a:rPr sz="1400" b="0">
+              <a:rPr sz="1300" b="0">
                 <a:solidFill>
                   <a:srgbClr val="1C1C1C"/>
                 </a:solidFill>
@@ -4465,8 +4464,8 @@
         </p:nvSpPr>
         <p:spPr>
           <a:xfrm>
-            <a:off x="5577840" y="3474720"/>
-            <a:ext cx="2788920" cy="548640"/>
+            <a:off x="6016752" y="3429000"/>
+            <a:ext cx="2651760" cy="640080"/>
           </a:xfrm>
           <a:prstGeom prst="rect">
             <a:avLst/>
@@ -4481,13 +4480,13 @@
           <a:p>
             <a:pPr algn="l"/>
             <a:r>
-              <a:rPr sz="1400" b="0">
+              <a:rPr sz="1300" b="0">
                 <a:solidFill>
                   <a:srgbClr val="1C1C1C"/>
                 </a:solidFill>
                 <a:latin typeface="Calibri"/>
               </a:rPr>
-              <a:t>Wajib inti</a:t>
+              <a:t>Harus jadi inti</a:t>
             </a:r>
           </a:p>
         </p:txBody>
@@ -4500,8 +4499,8 @@
         </p:nvSpPr>
         <p:spPr>
           <a:xfrm>
-            <a:off x="8503919" y="3474720"/>
-            <a:ext cx="2880360" cy="548640"/>
+            <a:off x="8759952" y="3429000"/>
+            <a:ext cx="2651760" cy="640080"/>
           </a:xfrm>
           <a:prstGeom prst="rect">
             <a:avLst/>
@@ -4516,13 +4515,13 @@
           <a:p>
             <a:pPr algn="l"/>
             <a:r>
-              <a:rPr sz="1400" b="0">
+              <a:rPr sz="1300" b="0">
                 <a:solidFill>
                   <a:srgbClr val="1C1C1C"/>
                 </a:solidFill>
                 <a:latin typeface="Calibri"/>
               </a:rPr>
-              <a:t>Sangat sentral</a:t>
+              <a:t>Sangat penting</a:t>
             </a:r>
           </a:p>
         </p:txBody>
@@ -4578,8 +4577,8 @@
         </p:nvSpPr>
         <p:spPr>
           <a:xfrm>
-            <a:off x="640080" y="4571999"/>
-            <a:ext cx="1874520" cy="548640"/>
+            <a:off x="621792" y="4526279"/>
+            <a:ext cx="2651760" cy="640080"/>
           </a:xfrm>
           <a:prstGeom prst="rect">
             <a:avLst/>
@@ -4594,13 +4593,13 @@
           <a:p>
             <a:pPr algn="l"/>
             <a:r>
-              <a:rPr sz="1400" b="1">
+              <a:rPr sz="1300" b="1">
                 <a:solidFill>
                   <a:srgbClr val="0F2C4C"/>
                 </a:solidFill>
                 <a:latin typeface="Calibri"/>
               </a:rPr>
-              <a:t>Contoh</a:t>
+              <a:t>Contoh dekat</a:t>
             </a:r>
           </a:p>
         </p:txBody>
@@ -4613,8 +4612,8 @@
         </p:nvSpPr>
         <p:spPr>
           <a:xfrm>
-            <a:off x="2651760" y="4571999"/>
-            <a:ext cx="2788920" cy="548640"/>
+            <a:off x="3364992" y="4526279"/>
+            <a:ext cx="2560320" cy="640080"/>
           </a:xfrm>
           <a:prstGeom prst="rect">
             <a:avLst/>
@@ -4629,7 +4628,7 @@
           <a:p>
             <a:pPr algn="l"/>
             <a:r>
-              <a:rPr sz="1400" b="0">
+              <a:rPr sz="1300" b="0">
                 <a:solidFill>
                   <a:srgbClr val="1C1C1C"/>
                 </a:solidFill>
@@ -4648,8 +4647,8 @@
         </p:nvSpPr>
         <p:spPr>
           <a:xfrm>
-            <a:off x="5577840" y="4571999"/>
-            <a:ext cx="2788920" cy="548640"/>
+            <a:off x="6016752" y="4526279"/>
+            <a:ext cx="2651760" cy="640080"/>
           </a:xfrm>
           <a:prstGeom prst="rect">
             <a:avLst/>
@@ -4664,13 +4663,13 @@
           <a:p>
             <a:pPr algn="l"/>
             <a:r>
-              <a:rPr sz="1400" b="0">
+              <a:rPr sz="1300" b="0">
                 <a:solidFill>
                   <a:srgbClr val="1C1C1C"/>
                 </a:solidFill>
                 <a:latin typeface="Calibri"/>
               </a:rPr>
-              <a:t>App IoT pertanian</a:t>
+              <a:t>App antrean, kasir cloud</a:t>
             </a:r>
           </a:p>
         </p:txBody>
@@ -4683,8 +4682,8 @@
         </p:nvSpPr>
         <p:spPr>
           <a:xfrm>
-            <a:off x="8503919" y="4571999"/>
-            <a:ext cx="2880360" cy="548640"/>
+            <a:off x="8759952" y="4526279"/>
+            <a:ext cx="2651760" cy="640080"/>
           </a:xfrm>
           <a:prstGeom prst="rect">
             <a:avLst/>
@@ -4699,7 +4698,7 @@
           <a:p>
             <a:pPr algn="l"/>
             <a:r>
-              <a:rPr sz="1400" b="0">
+              <a:rPr sz="1300" b="0">
                 <a:solidFill>
                   <a:srgbClr val="1C1C1C"/>
                 </a:solidFill>
@@ -4740,7 +4739,7 @@
                 </a:solidFill>
                 <a:latin typeface="Calibri"/>
               </a:rPr>
-              <a:t>Technopreneurship · S1 Bisnis Digital Sem 3 · Sub-CPMK 1.1</a:t>
+              <a:t>Technopreneurship · Bisnis Digital Sem 3 · Sub-CPMK 1.1</a:t>
             </a:r>
           </a:p>
         </p:txBody>
@@ -4908,13 +4907,13 @@
           <a:p>
             <a:pPr algn="l"/>
             <a:r>
-              <a:rPr sz="2800" b="1">
+              <a:rPr sz="2600" b="1">
                 <a:solidFill>
                   <a:srgbClr val="0F2C4C"/>
                 </a:solidFill>
                 <a:latin typeface="Calibri"/>
               </a:rPr>
-              <a:t>Belajar dari kasus Indonesia</a:t>
+              <a:t>Belajar dari cerita Indonesia</a:t>
             </a:r>
           </a:p>
         </p:txBody>
@@ -4949,7 +4948,7 @@
                 </a:solidFill>
                 <a:latin typeface="Calibri"/>
               </a:rPr>
-              <a:t>Masalah → solusi → teknologi → model bisnis</a:t>
+              <a:t>Bukan untuk ditiru skalanya—tapi cara berpikirnya</a:t>
             </a:r>
           </a:p>
         </p:txBody>
@@ -5006,7 +5005,7 @@
         <p:spPr>
           <a:xfrm>
             <a:off x="548640" y="1371600"/>
-            <a:ext cx="2103120" cy="1280160"/>
+            <a:ext cx="2194560" cy="1280160"/>
           </a:xfrm>
           <a:prstGeom prst="rect">
             <a:avLst/>
@@ -5049,7 +5048,7 @@
         <p:spPr>
           <a:xfrm>
             <a:off x="685800" y="1783080"/>
-            <a:ext cx="1828800" cy="457200"/>
+            <a:ext cx="1920240" cy="457200"/>
           </a:xfrm>
           <a:prstGeom prst="rect">
             <a:avLst/>
@@ -5064,7 +5063,7 @@
           <a:p>
             <a:pPr algn="l"/>
             <a:r>
-              <a:rPr sz="2000" b="1">
+              <a:rPr sz="1800" b="1">
                 <a:solidFill>
                   <a:srgbClr val="FFFFFF"/>
                 </a:solidFill>
@@ -5083,8 +5082,8 @@
         </p:nvSpPr>
         <p:spPr>
           <a:xfrm>
-            <a:off x="2926080" y="1600200"/>
-            <a:ext cx="8321040" cy="411480"/>
+            <a:off x="3017520" y="1600200"/>
+            <a:ext cx="8229600" cy="365760"/>
           </a:xfrm>
           <a:prstGeom prst="rect">
             <a:avLst/>
@@ -5099,13 +5098,13 @@
           <a:p>
             <a:pPr algn="l"/>
             <a:r>
-              <a:rPr sz="1600" b="0">
+              <a:rPr sz="1500" b="0">
                 <a:solidFill>
                   <a:srgbClr val="1C1C1C"/>
                 </a:solidFill>
                 <a:latin typeface="Calibri"/>
               </a:rPr>
-              <a:t>Masalah ojek pangkalan sulit dipanggil</a:t>
+              <a:t>Orang susah panggil ojek tepat waktu</a:t>
             </a:r>
           </a:p>
         </p:txBody>
@@ -5118,8 +5117,8 @@
         </p:nvSpPr>
         <p:spPr>
           <a:xfrm>
-            <a:off x="2926080" y="2057400"/>
-            <a:ext cx="8321040" cy="411480"/>
+            <a:off x="3017520" y="2057400"/>
+            <a:ext cx="8229600" cy="365760"/>
           </a:xfrm>
           <a:prstGeom prst="rect">
             <a:avLst/>
@@ -5134,13 +5133,13 @@
           <a:p>
             <a:pPr algn="l"/>
             <a:r>
-              <a:rPr sz="1600" b="1">
+              <a:rPr sz="1500" b="1">
                 <a:solidFill>
                   <a:srgbClr val="0F2C4C"/>
                 </a:solidFill>
                 <a:latin typeface="Calibri"/>
               </a:rPr>
-              <a:t>Solusi: platform on-demand</a:t>
+              <a:t>Dibantu lewat aplikasi yang mempertemukan penumpang &amp; driver</a:t>
             </a:r>
           </a:p>
         </p:txBody>
@@ -5197,7 +5196,7 @@
         <p:spPr>
           <a:xfrm>
             <a:off x="548640" y="2834640"/>
-            <a:ext cx="2103120" cy="1280160"/>
+            <a:ext cx="2194560" cy="1280160"/>
           </a:xfrm>
           <a:prstGeom prst="rect">
             <a:avLst/>
@@ -5240,7 +5239,7 @@
         <p:spPr>
           <a:xfrm>
             <a:off x="685800" y="3246120"/>
-            <a:ext cx="1828800" cy="457200"/>
+            <a:ext cx="1920240" cy="457200"/>
           </a:xfrm>
           <a:prstGeom prst="rect">
             <a:avLst/>
@@ -5255,7 +5254,7 @@
           <a:p>
             <a:pPr algn="l"/>
             <a:r>
-              <a:rPr sz="2000" b="1">
+              <a:rPr sz="1800" b="1">
                 <a:solidFill>
                   <a:srgbClr val="FFFFFF"/>
                 </a:solidFill>
@@ -5274,8 +5273,8 @@
         </p:nvSpPr>
         <p:spPr>
           <a:xfrm>
-            <a:off x="2926080" y="3063240"/>
-            <a:ext cx="8321040" cy="411480"/>
+            <a:off x="3017520" y="3063240"/>
+            <a:ext cx="8229600" cy="365760"/>
           </a:xfrm>
           <a:prstGeom prst="rect">
             <a:avLst/>
@@ -5290,13 +5289,13 @@
           <a:p>
             <a:pPr algn="l"/>
             <a:r>
-              <a:rPr sz="1600" b="0">
+              <a:rPr sz="1500" b="0">
                 <a:solidFill>
                   <a:srgbClr val="1C1C1C"/>
                 </a:solidFill>
                 <a:latin typeface="Calibri"/>
               </a:rPr>
-              <a:t>Masalah jual-beli jarak jauh</a:t>
+              <a:t>Jual-beli jarak jauh ribet &amp; kurang percaya</a:t>
             </a:r>
           </a:p>
         </p:txBody>
@@ -5309,8 +5308,8 @@
         </p:nvSpPr>
         <p:spPr>
           <a:xfrm>
-            <a:off x="2926080" y="3520440"/>
-            <a:ext cx="8321040" cy="411480"/>
+            <a:off x="3017520" y="3520440"/>
+            <a:ext cx="8229600" cy="365760"/>
           </a:xfrm>
           <a:prstGeom prst="rect">
             <a:avLst/>
@@ -5325,13 +5324,13 @@
           <a:p>
             <a:pPr algn="l"/>
             <a:r>
-              <a:rPr sz="1600" b="1">
+              <a:rPr sz="1500" b="1">
                 <a:solidFill>
                   <a:srgbClr val="0F2C4C"/>
                 </a:solidFill>
                 <a:latin typeface="Calibri"/>
               </a:rPr>
-              <a:t>Solusi: marketplace digital</a:t>
+              <a:t>Dibantu lewat pasar online yang menampung banyak toko</a:t>
             </a:r>
           </a:p>
         </p:txBody>
@@ -5388,7 +5387,7 @@
         <p:spPr>
           <a:xfrm>
             <a:off x="548640" y="4297680"/>
-            <a:ext cx="2103120" cy="1280160"/>
+            <a:ext cx="2194560" cy="1280160"/>
           </a:xfrm>
           <a:prstGeom prst="rect">
             <a:avLst/>
@@ -5431,7 +5430,7 @@
         <p:spPr>
           <a:xfrm>
             <a:off x="685800" y="4709160"/>
-            <a:ext cx="1828800" cy="457200"/>
+            <a:ext cx="1920240" cy="457200"/>
           </a:xfrm>
           <a:prstGeom prst="rect">
             <a:avLst/>
@@ -5446,7 +5445,7 @@
           <a:p>
             <a:pPr algn="l"/>
             <a:r>
-              <a:rPr sz="2000" b="1">
+              <a:rPr sz="1800" b="1">
                 <a:solidFill>
                   <a:srgbClr val="FFFFFF"/>
                 </a:solidFill>
@@ -5465,8 +5464,8 @@
         </p:nvSpPr>
         <p:spPr>
           <a:xfrm>
-            <a:off x="2926080" y="4526280"/>
-            <a:ext cx="8321040" cy="411480"/>
+            <a:off x="3017520" y="4526280"/>
+            <a:ext cx="8229600" cy="365760"/>
           </a:xfrm>
           <a:prstGeom prst="rect">
             <a:avLst/>
@@ -5481,13 +5480,13 @@
           <a:p>
             <a:pPr algn="l"/>
             <a:r>
-              <a:rPr sz="1600" b="0">
+              <a:rPr sz="1500" b="0">
                 <a:solidFill>
                   <a:srgbClr val="1C1C1C"/>
                 </a:solidFill>
                 <a:latin typeface="Calibri"/>
               </a:rPr>
-              <a:t>Masalah booking perjalanan rumit</a:t>
+              <a:t>Booking perjalanan memakan waktu</a:t>
             </a:r>
           </a:p>
         </p:txBody>
@@ -5500,8 +5499,8 @@
         </p:nvSpPr>
         <p:spPr>
           <a:xfrm>
-            <a:off x="2926080" y="4983480"/>
-            <a:ext cx="8321040" cy="411480"/>
+            <a:off x="3017520" y="4983480"/>
+            <a:ext cx="8229600" cy="365760"/>
           </a:xfrm>
           <a:prstGeom prst="rect">
             <a:avLst/>
@@ -5516,13 +5515,13 @@
           <a:p>
             <a:pPr algn="l"/>
             <a:r>
-              <a:rPr sz="1600" b="1">
+              <a:rPr sz="1500" b="1">
                 <a:solidFill>
                   <a:srgbClr val="0F2C4C"/>
                 </a:solidFill>
                 <a:latin typeface="Calibri"/>
               </a:rPr>
-              <a:t>Solusi: agregator digital</a:t>
+              <a:t>Dibantu lewat satu tempat membandingkan &amp; memesan</a:t>
             </a:r>
           </a:p>
         </p:txBody>
@@ -5557,7 +5556,7 @@
                 </a:solidFill>
                 <a:latin typeface="Calibri"/>
               </a:rPr>
-              <a:t>Technopreneurship · S1 Bisnis Digital Sem 3 · Sub-CPMK 1.1</a:t>
+              <a:t>Technopreneurship · Bisnis Digital Sem 3 · Sub-CPMK 1.1</a:t>
             </a:r>
           </a:p>
         </p:txBody>
@@ -5725,13 +5724,13 @@
           <a:p>
             <a:pPr algn="l"/>
             <a:r>
-              <a:rPr sz="2800" b="1">
+              <a:rPr sz="2600" b="1">
                 <a:solidFill>
                   <a:srgbClr val="0F2C4C"/>
                 </a:solidFill>
                 <a:latin typeface="Calibri"/>
               </a:rPr>
-              <a:t>Pesan penting untuk pemula</a:t>
+              <a:t>Pesan hangat untuk pemula</a:t>
             </a:r>
           </a:p>
         </p:txBody>
@@ -5766,7 +5765,7 @@
                 </a:solidFill>
                 <a:latin typeface="Calibri"/>
               </a:rPr>
-              <a:t>Hindari mitos “langsung sukses”</a:t>
+              <a:t>Anda tidak harus langsung “jadi unicorn”</a:t>
             </a:r>
           </a:p>
         </p:txBody>
@@ -5844,8 +5843,8 @@
                 </a:solidFill>
                 <a:latin typeface="Calibri"/>
               </a:rPr>
-              <a:t>Yang kita tiru bukan skalanya,
-tetapi logika berpikirnya.</a:t>
+              <a:t>Yang kita tiru adalah kepedulian
+dan cara berpikirnya.</a:t>
             </a:r>
           </a:p>
         </p:txBody>
@@ -5874,13 +5873,13 @@
           <a:p>
             <a:pPr algn="ctr"/>
             <a:r>
-              <a:rPr sz="1800" b="0">
+              <a:rPr sz="1700" b="0">
                 <a:solidFill>
                   <a:srgbClr val="E6EEF2"/>
                 </a:solidFill>
                 <a:latin typeface="Calibri"/>
               </a:rPr>
-              <a:t>Masalah nyata → solusi relevan → teknologi yang tepat → model bisnis yang masuk akal.</a:t>
+              <a:t>Lihat masalah orang → tawarkan bantuan → jika perlu, pakai teknologi → pastikan cara dapat uangnya masuk akal.</a:t>
             </a:r>
           </a:p>
         </p:txBody>
@@ -5915,7 +5914,7 @@
                 </a:solidFill>
                 <a:latin typeface="Calibri"/>
               </a:rPr>
-              <a:t>Technopreneurship · S1 Bisnis Digital Sem 3 · Sub-CPMK 1.1</a:t>
+              <a:t>Technopreneurship · Bisnis Digital Sem 3 · Sub-CPMK 1.1</a:t>
             </a:r>
           </a:p>
         </p:txBody>
@@ -6083,13 +6082,13 @@
           <a:p>
             <a:pPr algn="l"/>
             <a:r>
-              <a:rPr sz="2800" b="1">
+              <a:rPr sz="2600" b="1">
                 <a:solidFill>
                   <a:srgbClr val="0F2C4C"/>
                 </a:solidFill>
                 <a:latin typeface="Calibri"/>
               </a:rPr>
-              <a:t>Cek pemahaman cepat</a:t>
+              <a:t>Coba jawab bersama</a:t>
             </a:r>
           </a:p>
         </p:txBody>
@@ -6124,7 +6123,7 @@
                 </a:solidFill>
                 <a:latin typeface="Calibri"/>
               </a:rPr>
-              <a:t>Angkat tangan / jawab singkat</a:t>
+              <a:t>Latihan singkat—tidak ada yang salah untuk belajar</a:t>
             </a:r>
           </a:p>
         </p:txBody>
@@ -6274,13 +6273,13 @@
           <a:p>
             <a:pPr algn="l"/>
             <a:r>
-              <a:rPr sz="1600" b="1">
+              <a:rPr sz="1500" b="1">
                 <a:solidFill>
                   <a:srgbClr val="0F2C4C"/>
                 </a:solidFill>
                 <a:latin typeface="Calibri"/>
               </a:rPr>
-              <a:t>Laundry hanya pakai WhatsApp untuk order. Apakah otomatis technopreneur?</a:t>
+              <a:t>Laundry hanya terima order lewat WhatsApp. Apakah otomatis technopreneur?</a:t>
             </a:r>
           </a:p>
         </p:txBody>
@@ -6315,7 +6314,7 @@
                 </a:solidFill>
                 <a:latin typeface="Calibri"/>
               </a:rPr>
-              <a:t>Kunci: Umumnya belum — baru digitalisasi ringan.</a:t>
+              <a:t>Arah jawaban: Biasanya belum. Itu digitalisasi ringan.</a:t>
             </a:r>
           </a:p>
         </p:txBody>
@@ -6465,13 +6464,13 @@
           <a:p>
             <a:pPr algn="l"/>
             <a:r>
-              <a:rPr sz="1600" b="1">
+              <a:rPr sz="1500" b="1">
                 <a:solidFill>
                   <a:srgbClr val="0F2C4C"/>
                 </a:solidFill>
                 <a:latin typeface="Calibri"/>
               </a:rPr>
-              <a:t>Aplikasi monitoring tanaman + langganan sensor. Technopreneur?</a:t>
+              <a:t>Ada aplikasi pantau tanaman + layanan sensor berbayar. Technopreneur?</a:t>
             </a:r>
           </a:p>
         </p:txBody>
@@ -6506,7 +6505,7 @@
                 </a:solidFill>
                 <a:latin typeface="Calibri"/>
               </a:rPr>
-              <a:t>Kunci: Ya — teknologi menjadi inti nilai.</a:t>
+              <a:t>Arah jawaban: Arahnya ya—teknologi jadi jantung layanan.</a:t>
             </a:r>
           </a:p>
         </p:txBody>
@@ -6656,13 +6655,13 @@
           <a:p>
             <a:pPr algn="l"/>
             <a:r>
-              <a:rPr sz="1600" b="1">
+              <a:rPr sz="1500" b="1">
                 <a:solidFill>
                   <a:srgbClr val="0F2C4C"/>
                 </a:solidFill>
                 <a:latin typeface="Calibri"/>
               </a:rPr>
-              <a:t>Toko fashion yang jual utama lewat marketplace + konten digital. Bisnis digital?</a:t>
+              <a:t>Toko baju yang utamanya jualan di marketplace + konten. Bisnis digital?</a:t>
             </a:r>
           </a:p>
         </p:txBody>
@@ -6697,7 +6696,7 @@
                 </a:solidFill>
                 <a:latin typeface="Calibri"/>
               </a:rPr>
-              <a:t>Kunci: Ya — nilai utamanya di ruang digital.</a:t>
+              <a:t>Arah jawaban: Ya—hidup usahanya di ruang online.</a:t>
             </a:r>
           </a:p>
         </p:txBody>
@@ -6732,7 +6731,7 @@
                 </a:solidFill>
                 <a:latin typeface="Calibri"/>
               </a:rPr>
-              <a:t>Technopreneurship · S1 Bisnis Digital Sem 3 · Sub-CPMK 1.1</a:t>
+              <a:t>Technopreneurship · Bisnis Digital Sem 3 · Sub-CPMK 1.1</a:t>
             </a:r>
           </a:p>
         </p:txBody>
@@ -6900,13 +6899,13 @@
           <a:p>
             <a:pPr algn="l"/>
             <a:r>
-              <a:rPr sz="2800" b="1">
+              <a:rPr sz="2600" b="1">
                 <a:solidFill>
                   <a:srgbClr val="0F2C4C"/>
                 </a:solidFill>
                 <a:latin typeface="Calibri"/>
               </a:rPr>
-              <a:t>Aktivitas kelas (±35 menit)</a:t>
+              <a:t>Latihan berpasangan (±35 menit)</a:t>
             </a:r>
           </a:p>
         </p:txBody>
@@ -6941,7 +6940,7 @@
                 </a:solidFill>
                 <a:latin typeface="Calibri"/>
               </a:rPr>
-              <a:t>Kerja berpasangan</a:t>
+              <a:t>Praktik kecil yang bisa langsung dikerjakan</a:t>
             </a:r>
           </a:p>
         </p:txBody>
@@ -7075,8 +7074,8 @@
         </p:nvSpPr>
         <p:spPr>
           <a:xfrm>
-            <a:off x="2057400" y="1600200"/>
-            <a:ext cx="9235440" cy="457200"/>
+            <a:off x="2057400" y="1554480"/>
+            <a:ext cx="9235440" cy="502920"/>
           </a:xfrm>
           <a:prstGeom prst="rect">
             <a:avLst/>
@@ -7091,13 +7090,13 @@
           <a:p>
             <a:pPr algn="l"/>
             <a:r>
-              <a:rPr sz="1800" b="0">
+              <a:rPr sz="1600" b="0">
                 <a:solidFill>
                   <a:srgbClr val="1C1C1C"/>
                 </a:solidFill>
                 <a:latin typeface="Calibri"/>
               </a:rPr>
-              <a:t>Tuliskan 1 usaha offline di sekitar kampus.</a:t>
+              <a:t>Pilih 1 usaha offline di sekitar kampus (warung, fotokopi, laundry, dll.).</a:t>
             </a:r>
           </a:p>
         </p:txBody>
@@ -7231,8 +7230,8 @@
         </p:nvSpPr>
         <p:spPr>
           <a:xfrm>
-            <a:off x="2057400" y="2697480"/>
-            <a:ext cx="9235440" cy="457200"/>
+            <a:off x="2057400" y="2651760"/>
+            <a:ext cx="9235440" cy="502920"/>
           </a:xfrm>
           <a:prstGeom prst="rect">
             <a:avLst/>
@@ -7247,13 +7246,13 @@
           <a:p>
             <a:pPr algn="l"/>
             <a:r>
-              <a:rPr sz="1800" b="0">
+              <a:rPr sz="1600" b="0">
                 <a:solidFill>
                   <a:srgbClr val="1C1C1C"/>
                 </a:solidFill>
                 <a:latin typeface="Calibri"/>
               </a:rPr>
-              <a:t>Bayangkan versi technopreneur-nya: teknologi apa yang jadi inti solusi?</a:t>
+              <a:t>Ceritakan versi technopreneur-nya: teknologi apa yang benar-benar jadi inti bantuan?</a:t>
             </a:r>
           </a:p>
         </p:txBody>
@@ -7387,8 +7386,8 @@
         </p:nvSpPr>
         <p:spPr>
           <a:xfrm>
-            <a:off x="2057400" y="3794760"/>
-            <a:ext cx="9235440" cy="457200"/>
+            <a:off x="2057400" y="3749039"/>
+            <a:ext cx="9235440" cy="502920"/>
           </a:xfrm>
           <a:prstGeom prst="rect">
             <a:avLst/>
@@ -7403,13 +7402,13 @@
           <a:p>
             <a:pPr algn="l"/>
             <a:r>
-              <a:rPr sz="1800" b="0">
+              <a:rPr sz="1600" b="0">
                 <a:solidFill>
                   <a:srgbClr val="1C1C1C"/>
                 </a:solidFill>
                 <a:latin typeface="Calibri"/>
               </a:rPr>
-              <a:t>Bayangkan versi bisnis digital-nya: kanal &amp; cara dapat uang secara digital apa?</a:t>
+              <a:t>Ceritakan versi bisnis digital-nya: di mana bertemu pelanggan online &amp; bagaimana dibayar?</a:t>
             </a:r>
           </a:p>
         </p:txBody>
@@ -7543,8 +7542,8 @@
         </p:nvSpPr>
         <p:spPr>
           <a:xfrm>
-            <a:off x="2057400" y="4892040"/>
-            <a:ext cx="9235440" cy="457200"/>
+            <a:off x="2057400" y="4846320"/>
+            <a:ext cx="9235440" cy="502920"/>
           </a:xfrm>
           <a:prstGeom prst="rect">
             <a:avLst/>
@@ -7559,13 +7558,13 @@
           <a:p>
             <a:pPr algn="l"/>
             <a:r>
-              <a:rPr sz="1800" b="0">
+              <a:rPr sz="1600" b="0">
                 <a:solidFill>
                   <a:srgbClr val="1C1C1C"/>
                 </a:solidFill>
                 <a:latin typeface="Calibri"/>
               </a:rPr>
-              <a:t>Presentasikan singkat (2 menit) — 3 pasangan maju.</a:t>
+              <a:t>Sampaikan ke kelas dalam 2 menit—seperti cerita ke teman, bukan baca kamus.</a:t>
             </a:r>
           </a:p>
         </p:txBody>
@@ -7600,7 +7599,7 @@
                 </a:solidFill>
                 <a:latin typeface="Calibri"/>
               </a:rPr>
-              <a:t>Technopreneurship · S1 Bisnis Digital Sem 3 · Sub-CPMK 1.1</a:t>
+              <a:t>Technopreneurship · Bisnis Digital Sem 3 · Sub-CPMK 1.1</a:t>
             </a:r>
           </a:p>
         </p:txBody>
@@ -7768,13 +7767,13 @@
           <a:p>
             <a:pPr algn="l"/>
             <a:r>
-              <a:rPr sz="2800" b="1">
+              <a:rPr sz="2600" b="1">
                 <a:solidFill>
                   <a:srgbClr val="0F2C4C"/>
                 </a:solidFill>
                 <a:latin typeface="Calibri"/>
               </a:rPr>
-              <a:t>Ringkasan Sub-CPMK 1.1</a:t>
+              <a:t>Simpulan singkat</a:t>
             </a:r>
           </a:p>
         </p:txBody>
@@ -7809,7 +7808,7 @@
                 </a:solidFill>
                 <a:latin typeface="Calibri"/>
               </a:rPr>
-              <a:t>Tiga kalimat yang wajib diingat</a:t>
+              <a:t>Bawa pulang tiga kalimat ini</a:t>
             </a:r>
           </a:p>
         </p:txBody>
@@ -7965,7 +7964,7 @@
                 </a:solidFill>
                 <a:latin typeface="Calibri"/>
               </a:rPr>
-              <a:t>Melihat peluang dan menciptakan nilai; teknologi boleh pendukung.</a:t>
+              <a:t>Orang yang mengubah keluhan menjadi peluang dan manfaat.</a:t>
             </a:r>
           </a:p>
         </p:txBody>
@@ -8121,7 +8120,7 @@
                 </a:solidFill>
                 <a:latin typeface="Calibri"/>
               </a:rPr>
-              <a:t>Entrepreneur yang menjadikan teknologi sebagai inti solusi.</a:t>
+              <a:t>Entrepreneur yang menaruh teknologi di pusat solusinya.</a:t>
             </a:r>
           </a:p>
         </p:txBody>
@@ -8277,7 +8276,7 @@
                 </a:solidFill>
                 <a:latin typeface="Calibri"/>
               </a:rPr>
-              <a:t>Usaha yang menghasilkan nilai utama melalui ruang digital.</a:t>
+              <a:t>Usaha yang hidup utamanya lewat jalur dan ruang online.</a:t>
             </a:r>
           </a:p>
         </p:txBody>
@@ -8312,7 +8311,7 @@
                 </a:solidFill>
                 <a:latin typeface="Calibri"/>
               </a:rPr>
-              <a:t>Technopreneurship · S1 Bisnis Digital Sem 3 · Sub-CPMK 1.1</a:t>
+              <a:t>Technopreneurship · Bisnis Digital Sem 3 · Sub-CPMK 1.1</a:t>
             </a:r>
           </a:p>
         </p:txBody>
@@ -8480,13 +8479,13 @@
           <a:p>
             <a:pPr algn="l"/>
             <a:r>
-              <a:rPr sz="2800" b="1">
+              <a:rPr sz="2600" b="1">
                 <a:solidFill>
                   <a:srgbClr val="0F2C4C"/>
                 </a:solidFill>
                 <a:latin typeface="Calibri"/>
               </a:rPr>
-              <a:t>Tugas rumah</a:t>
+              <a:t>Tugas kecil untuk rumah</a:t>
             </a:r>
           </a:p>
         </p:txBody>
@@ -8521,7 +8520,7 @@
                 </a:solidFill>
                 <a:latin typeface="Calibri"/>
               </a:rPr>
-              <a:t>Persiapan pertemuan berikutnya</a:t>
+              <a:t>Latihan melihat dengan mata manusia</a:t>
             </a:r>
           </a:p>
         </p:txBody>
@@ -8535,7 +8534,7 @@
         <p:spPr>
           <a:xfrm>
             <a:off x="548640" y="1371600"/>
-            <a:ext cx="11064240" cy="4206240"/>
+            <a:ext cx="11064240" cy="4297680"/>
           </a:xfrm>
           <a:prstGeom prst="roundRect">
             <a:avLst/>
@@ -8593,13 +8592,13 @@
           <a:p>
             <a:pPr algn="l"/>
             <a:r>
-              <a:rPr sz="2000" b="1">
+              <a:rPr sz="1800" b="1">
                 <a:solidFill>
                   <a:srgbClr val="0F2C4C"/>
                 </a:solidFill>
                 <a:latin typeface="Calibri"/>
               </a:rPr>
-              <a:t>Cari 1 startup Indonesia, lalu tulis 5 kalimat:</a:t>
+              <a:t>Pilih 1 startup Indonesia. Tulis 5 kalimat seperti bercerita:</a:t>
             </a:r>
           </a:p>
         </p:txBody>
@@ -8638,7 +8637,7 @@
                 </a:solidFill>
                 <a:latin typeface="Calibri"/>
               </a:rPr>
-              <a:t>1. Masalah apa yang diselesaikan?</a:t>
+              <a:t>1. Orang apa yang dibantu?</a:t>
             </a:r>
           </a:p>
           <a:p>
@@ -8654,7 +8653,7 @@
                 </a:solidFill>
                 <a:latin typeface="Calibri"/>
               </a:rPr>
-              <a:t>2. Solusinya apa?</a:t>
+              <a:t>2. Kesulitan apa yang mereka rasakan?</a:t>
             </a:r>
           </a:p>
           <a:p>
@@ -8670,7 +8669,7 @@
                 </a:solidFill>
                 <a:latin typeface="Calibri"/>
               </a:rPr>
-              <a:t>3. Teknologi apa yang dipakai?</a:t>
+              <a:t>3. Bantuan apa yang ditawarkan?</a:t>
             </a:r>
           </a:p>
           <a:p>
@@ -8686,7 +8685,7 @@
                 </a:solidFill>
                 <a:latin typeface="Calibri"/>
               </a:rPr>
-              <a:t>4. Siapa penggunanya?</a:t>
+              <a:t>4. Teknologi apa yang membuat bantuan itu mungkin?</a:t>
             </a:r>
           </a:p>
           <a:p>
@@ -8702,7 +8701,7 @@
                 </a:solidFill>
                 <a:latin typeface="Calibri"/>
               </a:rPr>
-              <a:t>5. Bagaimana cara mendapatkan uang?</a:t>
+              <a:t>5. Bagaimana mereka mendapat penghasilan?</a:t>
             </a:r>
           </a:p>
         </p:txBody>
@@ -8715,7 +8714,7 @@
         </p:nvSpPr>
         <p:spPr>
           <a:xfrm>
-            <a:off x="914400" y="4937760"/>
+            <a:off x="914400" y="5029200"/>
             <a:ext cx="10332720" cy="365760"/>
           </a:xfrm>
           <a:prstGeom prst="rect">
@@ -8737,7 +8736,7 @@
                 </a:solidFill>
                 <a:latin typeface="Calibri"/>
               </a:rPr>
-              <a:t>Kumpulkan di LMS sebelum pertemuan berikutnya.</a:t>
+              <a:t>Kumpulkan di LMS. Panjang tidak perlu—yang penting jernih.</a:t>
             </a:r>
           </a:p>
         </p:txBody>
@@ -8772,7 +8771,7 @@
                 </a:solidFill>
                 <a:latin typeface="Calibri"/>
               </a:rPr>
-              <a:t>Technopreneurship · S1 Bisnis Digital Sem 3 · Sub-CPMK 1.1</a:t>
+              <a:t>Technopreneurship · Bisnis Digital Sem 3 · Sub-CPMK 1.1</a:t>
             </a:r>
           </a:p>
         </p:txBody>
@@ -8940,13 +8939,13 @@
           <a:p>
             <a:pPr algn="l"/>
             <a:r>
-              <a:rPr sz="2800" b="1">
+              <a:rPr sz="2600" b="1">
                 <a:solidFill>
                   <a:srgbClr val="0F2C4C"/>
                 </a:solidFill>
                 <a:latin typeface="Calibri"/>
               </a:rPr>
-              <a:t>Referensi &amp; penutup</a:t>
+              <a:t>Penutup</a:t>
             </a:r>
           </a:p>
         </p:txBody>
@@ -8981,7 +8980,7 @@
                 </a:solidFill>
                 <a:latin typeface="Calibri"/>
               </a:rPr>
-              <a:t>Sumber penyusunan materi</a:t>
+              <a:t>Sampai jumpa di pertemuan berikutnya</a:t>
             </a:r>
           </a:p>
         </p:txBody>
@@ -8994,14 +8993,14 @@
         </p:nvSpPr>
         <p:spPr>
           <a:xfrm>
-            <a:off x="548640" y="1463040"/>
-            <a:ext cx="11064240" cy="914400"/>
+            <a:off x="1097280" y="1645920"/>
+            <a:ext cx="9966960" cy="3840480"/>
           </a:xfrm>
           <a:prstGeom prst="roundRect">
             <a:avLst/>
           </a:prstGeom>
           <a:solidFill>
-            <a:srgbClr val="FFFFFF"/>
+            <a:srgbClr val="0F2C4C"/>
           </a:solidFill>
           <a:ln>
             <a:noFill/>
@@ -9037,227 +9036,72 @@
         </p:nvSpPr>
         <p:spPr>
           <a:xfrm>
-            <a:off x="914400" y="1719072"/>
-            <a:ext cx="10332720" cy="502920"/>
-          </a:xfrm>
-          <a:prstGeom prst="rect">
-            <a:avLst/>
-          </a:prstGeom>
-          <a:noFill/>
-        </p:spPr>
-        <p:txBody>
-          <a:bodyPr wrap="square">
-            <a:spAutoFit/>
-          </a:bodyPr>
-          <a:lstStyle/>
-          <a:p>
-            <a:pPr algn="l"/>
+            <a:off x="1645920" y="2286000"/>
+            <a:ext cx="8869680" cy="1097280"/>
+          </a:xfrm>
+          <a:prstGeom prst="rect">
+            <a:avLst/>
+          </a:prstGeom>
+          <a:noFill/>
+        </p:spPr>
+        <p:txBody>
+          <a:bodyPr wrap="square">
+            <a:spAutoFit/>
+          </a:bodyPr>
+          <a:lstStyle/>
+          <a:p>
+            <a:pPr algn="ctr"/>
+            <a:r>
+              <a:rPr sz="3000" b="1">
+                <a:solidFill>
+                  <a:srgbClr val="FFFFFF"/>
+                </a:solidFill>
+                <a:latin typeface="Calibri"/>
+              </a:rPr>
+              <a:t>Bedakan dulu istilahnya.
+Baru bangun idenya.</a:t>
+            </a:r>
+          </a:p>
+        </p:txBody>
+      </p:sp>
+      <p:sp>
+        <p:nvSpPr>
+          <p:cNvPr id="8" name="TextBox 7"/>
+          <p:cNvSpPr txBox="1"/>
+          <p:nvPr/>
+        </p:nvSpPr>
+        <p:spPr>
+          <a:xfrm>
+            <a:off x="1645920" y="3931920"/>
+            <a:ext cx="8869680" cy="1097280"/>
+          </a:xfrm>
+          <a:prstGeom prst="rect">
+            <a:avLst/>
+          </a:prstGeom>
+          <a:noFill/>
+        </p:spPr>
+        <p:txBody>
+          <a:bodyPr wrap="square">
+            <a:spAutoFit/>
+          </a:bodyPr>
+          <a:lstStyle/>
+          <a:p>
+            <a:pPr algn="ctr"/>
             <a:r>
               <a:rPr sz="1600" b="0">
                 <a:solidFill>
-                  <a:srgbClr val="1C1C1C"/>
-                </a:solidFill>
-                <a:latin typeface="Calibri"/>
-              </a:rPr>
-              <a:t>Utama: Sulistyandari. Technopreneurship: Membangun Bisnis Berbasis Teknologi. Penerbit Adab.</a:t>
-            </a:r>
-          </a:p>
-        </p:txBody>
-      </p:sp>
-      <p:sp>
-        <p:nvSpPr>
-          <p:cNvPr id="8" name="Rounded Rectangle 7"/>
-          <p:cNvSpPr/>
-          <p:nvPr/>
-        </p:nvSpPr>
-        <p:spPr>
-          <a:xfrm>
-            <a:off x="548640" y="2560320"/>
-            <a:ext cx="11064240" cy="914400"/>
-          </a:xfrm>
-          <a:prstGeom prst="roundRect">
-            <a:avLst/>
-          </a:prstGeom>
-          <a:solidFill>
-            <a:srgbClr val="FFFFFF"/>
-          </a:solidFill>
-          <a:ln>
-            <a:noFill/>
-          </a:ln>
-        </p:spPr>
-        <p:style>
-          <a:lnRef idx="1">
-            <a:schemeClr val="accent1"/>
-          </a:lnRef>
-          <a:fillRef idx="3">
-            <a:schemeClr val="accent1"/>
-          </a:fillRef>
-          <a:effectRef idx="2">
-            <a:schemeClr val="accent1"/>
-          </a:effectRef>
-          <a:fontRef idx="minor">
-            <a:schemeClr val="lt1"/>
-          </a:fontRef>
-        </p:style>
-        <p:txBody>
-          <a:bodyPr rtlCol="0" anchor="ctr"/>
-          <a:lstStyle/>
-          <a:p>
-            <a:pPr algn="ctr"/>
+                  <a:srgbClr val="E6EEF2"/>
+                </a:solidFill>
+                <a:latin typeface="Calibri"/>
+              </a:rPr>
+              <a:t>Berikutnya: kita bahas teknologi sehari-hari (platform, pembayaran digital, AI, IoT) dengan bahasa yang sama sederhananya.</a:t>
+            </a:r>
           </a:p>
         </p:txBody>
       </p:sp>
       <p:sp>
         <p:nvSpPr>
           <p:cNvPr id="9" name="TextBox 8"/>
-          <p:cNvSpPr txBox="1"/>
-          <p:nvPr/>
-        </p:nvSpPr>
-        <p:spPr>
-          <a:xfrm>
-            <a:off x="914400" y="2816352"/>
-            <a:ext cx="10332720" cy="502920"/>
-          </a:xfrm>
-          <a:prstGeom prst="rect">
-            <a:avLst/>
-          </a:prstGeom>
-          <a:noFill/>
-        </p:spPr>
-        <p:txBody>
-          <a:bodyPr wrap="square">
-            <a:spAutoFit/>
-          </a:bodyPr>
-          <a:lstStyle/>
-          <a:p>
-            <a:pPr algn="l"/>
-            <a:r>
-              <a:rPr sz="1600" b="0">
-                <a:solidFill>
-                  <a:srgbClr val="1C1C1C"/>
-                </a:solidFill>
-                <a:latin typeface="Calibri"/>
-              </a:rPr>
-              <a:t>Naskah kelas: materi-technopreneurship/naskah/P02_konsep_dasar.md</a:t>
-            </a:r>
-          </a:p>
-        </p:txBody>
-      </p:sp>
-      <p:sp>
-        <p:nvSpPr>
-          <p:cNvPr id="10" name="Rounded Rectangle 9"/>
-          <p:cNvSpPr/>
-          <p:nvPr/>
-        </p:nvSpPr>
-        <p:spPr>
-          <a:xfrm>
-            <a:off x="548640" y="3657600"/>
-            <a:ext cx="11064240" cy="914400"/>
-          </a:xfrm>
-          <a:prstGeom prst="roundRect">
-            <a:avLst/>
-          </a:prstGeom>
-          <a:solidFill>
-            <a:srgbClr val="FFFFFF"/>
-          </a:solidFill>
-          <a:ln>
-            <a:noFill/>
-          </a:ln>
-        </p:spPr>
-        <p:style>
-          <a:lnRef idx="1">
-            <a:schemeClr val="accent1"/>
-          </a:lnRef>
-          <a:fillRef idx="3">
-            <a:schemeClr val="accent1"/>
-          </a:fillRef>
-          <a:effectRef idx="2">
-            <a:schemeClr val="accent1"/>
-          </a:effectRef>
-          <a:fontRef idx="minor">
-            <a:schemeClr val="lt1"/>
-          </a:fontRef>
-        </p:style>
-        <p:txBody>
-          <a:bodyPr rtlCol="0" anchor="ctr"/>
-          <a:lstStyle/>
-          <a:p>
-            <a:pPr algn="ctr"/>
-          </a:p>
-        </p:txBody>
-      </p:sp>
-      <p:sp>
-        <p:nvSpPr>
-          <p:cNvPr id="11" name="TextBox 10"/>
-          <p:cNvSpPr txBox="1"/>
-          <p:nvPr/>
-        </p:nvSpPr>
-        <p:spPr>
-          <a:xfrm>
-            <a:off x="914400" y="3913632"/>
-            <a:ext cx="10332720" cy="502920"/>
-          </a:xfrm>
-          <a:prstGeom prst="rect">
-            <a:avLst/>
-          </a:prstGeom>
-          <a:noFill/>
-        </p:spPr>
-        <p:txBody>
-          <a:bodyPr wrap="square">
-            <a:spAutoFit/>
-          </a:bodyPr>
-          <a:lstStyle/>
-          <a:p>
-            <a:pPr algn="l"/>
-            <a:r>
-              <a:rPr sz="1600" b="0">
-                <a:solidFill>
-                  <a:srgbClr val="1C1C1C"/>
-                </a:solidFill>
-                <a:latin typeface="Calibri"/>
-              </a:rPr>
-              <a:t>Berikutnya (Sub-CPMK 1.2): peran teknologi AI, IoT, fintech, dan platform dalam bisnis.</a:t>
-            </a:r>
-          </a:p>
-        </p:txBody>
-      </p:sp>
-      <p:sp>
-        <p:nvSpPr>
-          <p:cNvPr id="12" name="TextBox 11"/>
-          <p:cNvSpPr txBox="1"/>
-          <p:nvPr/>
-        </p:nvSpPr>
-        <p:spPr>
-          <a:xfrm>
-            <a:off x="548640" y="5029200"/>
-            <a:ext cx="11064240" cy="640080"/>
-          </a:xfrm>
-          <a:prstGeom prst="rect">
-            <a:avLst/>
-          </a:prstGeom>
-          <a:noFill/>
-        </p:spPr>
-        <p:txBody>
-          <a:bodyPr wrap="square">
-            <a:spAutoFit/>
-          </a:bodyPr>
-          <a:lstStyle/>
-          <a:p>
-            <a:pPr algn="ctr"/>
-            <a:r>
-              <a:rPr sz="2200" b="1">
-                <a:solidFill>
-                  <a:srgbClr val="0F2C4C"/>
-                </a:solidFill>
-                <a:latin typeface="Calibri"/>
-              </a:rPr>
-              <a:t>Bedakan dulu istilahnya. Baru bangun idenya.</a:t>
-            </a:r>
-          </a:p>
-        </p:txBody>
-      </p:sp>
-      <p:sp>
-        <p:nvSpPr>
-          <p:cNvPr id="13" name="TextBox 12"/>
           <p:cNvSpPr txBox="1"/>
           <p:nvPr/>
         </p:nvSpPr>
@@ -9285,14 +9129,14 @@
                 </a:solidFill>
                 <a:latin typeface="Calibri"/>
               </a:rPr>
-              <a:t>Technopreneurship · S1 Bisnis Digital Sem 3 · Sub-CPMK 1.1</a:t>
-            </a:r>
-          </a:p>
-        </p:txBody>
-      </p:sp>
-      <p:sp>
-        <p:nvSpPr>
-          <p:cNvPr id="14" name="TextBox 13"/>
+              <a:t>Technopreneurship · Bisnis Digital Sem 3 · Sub-CPMK 1.1</a:t>
+            </a:r>
+          </a:p>
+        </p:txBody>
+      </p:sp>
+      <p:sp>
+        <p:nvSpPr>
+          <p:cNvPr id="10" name="TextBox 9"/>
           <p:cNvSpPr txBox="1"/>
           <p:nvPr/>
         </p:nvSpPr>
@@ -9453,13 +9297,13 @@
           <a:p>
             <a:pPr algn="l"/>
             <a:r>
-              <a:rPr sz="2800" b="1">
+              <a:rPr sz="2600" b="1">
                 <a:solidFill>
                   <a:srgbClr val="0F2C4C"/>
                 </a:solidFill>
                 <a:latin typeface="Calibri"/>
               </a:rPr>
-              <a:t>Capaian Pembelajaran</a:t>
+              <a:t>Apa yang akan kita kuasai hari ini?</a:t>
             </a:r>
           </a:p>
         </p:txBody>
@@ -9494,7 +9338,7 @@
                 </a:solidFill>
                 <a:latin typeface="Calibri"/>
               </a:rPr>
-              <a:t>CPMK-1 dan Sub-CPMK 1.1</a:t>
+              <a:t>Jangan khawatir dengan istilah asing—kita bedah pelan-pelan</a:t>
             </a:r>
           </a:p>
         </p:txBody>
@@ -9508,7 +9352,7 @@
         <p:spPr>
           <a:xfrm>
             <a:off x="548640" y="1371600"/>
-            <a:ext cx="11064240" cy="1371600"/>
+            <a:ext cx="11064240" cy="4389120"/>
           </a:xfrm>
           <a:prstGeom prst="roundRect">
             <a:avLst/>
@@ -9550,8 +9394,8 @@
         </p:nvSpPr>
         <p:spPr>
           <a:xfrm>
-            <a:off x="822960" y="1508760"/>
-            <a:ext cx="10515600" cy="320040"/>
+            <a:off x="914400" y="1645920"/>
+            <a:ext cx="10332720" cy="457200"/>
           </a:xfrm>
           <a:prstGeom prst="rect">
             <a:avLst/>
@@ -9566,13 +9410,13 @@
           <a:p>
             <a:pPr algn="l"/>
             <a:r>
-              <a:rPr sz="1400" b="1">
-                <a:solidFill>
-                  <a:srgbClr val="1A6B6B"/>
-                </a:solidFill>
-                <a:latin typeface="Calibri"/>
-              </a:rPr>
-              <a:t>CPMK-1</a:t>
+              <a:rPr sz="1800" b="1">
+                <a:solidFill>
+                  <a:srgbClr val="0F2C4C"/>
+                </a:solidFill>
+                <a:latin typeface="Calibri"/>
+              </a:rPr>
+              <a:t>Di akhir pertemuan, Anda bisa:</a:t>
             </a:r>
           </a:p>
         </p:txBody>
@@ -9585,156 +9429,8 @@
         </p:nvSpPr>
         <p:spPr>
           <a:xfrm>
-            <a:off x="822960" y="1874519"/>
-            <a:ext cx="10515600" cy="640080"/>
-          </a:xfrm>
-          <a:prstGeom prst="rect">
-            <a:avLst/>
-          </a:prstGeom>
-          <a:noFill/>
-        </p:spPr>
-        <p:txBody>
-          <a:bodyPr wrap="square">
-            <a:spAutoFit/>
-          </a:bodyPr>
-          <a:lstStyle/>
-          <a:p>
-            <a:pPr algn="l"/>
-            <a:r>
-              <a:rPr sz="1800" b="0">
-                <a:solidFill>
-                  <a:srgbClr val="1C1C1C"/>
-                </a:solidFill>
-                <a:latin typeface="Calibri"/>
-              </a:rPr>
-              <a:t>Mahasiswa mampu menjelaskan konsep dasar entrepreneurship, technopreneurship, dan ekosistem bisnis digital Indonesia.</a:t>
-            </a:r>
-          </a:p>
-        </p:txBody>
-      </p:sp>
-      <p:sp>
-        <p:nvSpPr>
-          <p:cNvPr id="9" name="Rounded Rectangle 8"/>
-          <p:cNvSpPr/>
-          <p:nvPr/>
-        </p:nvSpPr>
-        <p:spPr>
-          <a:xfrm>
-            <a:off x="548640" y="3017520"/>
-            <a:ext cx="11064240" cy="2377440"/>
-          </a:xfrm>
-          <a:prstGeom prst="roundRect">
-            <a:avLst/>
-          </a:prstGeom>
-          <a:solidFill>
-            <a:srgbClr val="FFFFFF"/>
-          </a:solidFill>
-          <a:ln>
-            <a:noFill/>
-          </a:ln>
-        </p:spPr>
-        <p:style>
-          <a:lnRef idx="1">
-            <a:schemeClr val="accent1"/>
-          </a:lnRef>
-          <a:fillRef idx="3">
-            <a:schemeClr val="accent1"/>
-          </a:fillRef>
-          <a:effectRef idx="2">
-            <a:schemeClr val="accent1"/>
-          </a:effectRef>
-          <a:fontRef idx="minor">
-            <a:schemeClr val="lt1"/>
-          </a:fontRef>
-        </p:style>
-        <p:txBody>
-          <a:bodyPr rtlCol="0" anchor="ctr"/>
-          <a:lstStyle/>
-          <a:p>
-            <a:pPr algn="ctr"/>
-          </a:p>
-        </p:txBody>
-      </p:sp>
-      <p:sp>
-        <p:nvSpPr>
-          <p:cNvPr id="10" name="TextBox 9"/>
-          <p:cNvSpPr txBox="1"/>
-          <p:nvPr/>
-        </p:nvSpPr>
-        <p:spPr>
-          <a:xfrm>
-            <a:off x="822960" y="3200400"/>
-            <a:ext cx="10515600" cy="320040"/>
-          </a:xfrm>
-          <a:prstGeom prst="rect">
-            <a:avLst/>
-          </a:prstGeom>
-          <a:noFill/>
-        </p:spPr>
-        <p:txBody>
-          <a:bodyPr wrap="square">
-            <a:spAutoFit/>
-          </a:bodyPr>
-          <a:lstStyle/>
-          <a:p>
-            <a:pPr algn="l"/>
-            <a:r>
-              <a:rPr sz="1400" b="1">
-                <a:solidFill>
-                  <a:srgbClr val="D97B2A"/>
-                </a:solidFill>
-                <a:latin typeface="Calibri"/>
-              </a:rPr>
-              <a:t>Sub-CPMK 1.1 (fokus pertemuan ini)</a:t>
-            </a:r>
-          </a:p>
-        </p:txBody>
-      </p:sp>
-      <p:sp>
-        <p:nvSpPr>
-          <p:cNvPr id="11" name="TextBox 10"/>
-          <p:cNvSpPr txBox="1"/>
-          <p:nvPr/>
-        </p:nvSpPr>
-        <p:spPr>
-          <a:xfrm>
-            <a:off x="822960" y="3657600"/>
-            <a:ext cx="10515600" cy="457200"/>
-          </a:xfrm>
-          <a:prstGeom prst="rect">
-            <a:avLst/>
-          </a:prstGeom>
-          <a:noFill/>
-        </p:spPr>
-        <p:txBody>
-          <a:bodyPr wrap="square">
-            <a:spAutoFit/>
-          </a:bodyPr>
-          <a:lstStyle/>
-          <a:p>
-            <a:pPr algn="l"/>
-            <a:r>
-              <a:rPr sz="2200" b="1">
-                <a:solidFill>
-                  <a:srgbClr val="0F2C4C"/>
-                </a:solidFill>
-                <a:latin typeface="Calibri"/>
-              </a:rPr>
-              <a:t>Membedakan entrepreneur, technopreneur, dan bisnis digital.</a:t>
-            </a:r>
-          </a:p>
-        </p:txBody>
-      </p:sp>
-      <p:sp>
-        <p:nvSpPr>
-          <p:cNvPr id="12" name="TextBox 11"/>
-          <p:cNvSpPr txBox="1"/>
-          <p:nvPr/>
-        </p:nvSpPr>
-        <p:spPr>
-          <a:xfrm>
-            <a:off x="822960" y="4297680"/>
-            <a:ext cx="10515600" cy="914400"/>
+            <a:off x="914400" y="2286000"/>
+            <a:ext cx="10332720" cy="3017520"/>
           </a:xfrm>
           <a:prstGeom prst="rect">
             <a:avLst/>
@@ -9753,13 +9449,13 @@
               </a:spcAft>
             </a:pPr>
             <a:r>
-              <a:rPr sz="1500" b="0">
-                <a:solidFill>
-                  <a:srgbClr val="5A6570"/>
-                </a:solidFill>
-                <a:latin typeface="Calibri"/>
-              </a:rPr>
-              <a:t>Setelah kuliah ini, mahasiswa dapat:</a:t>
+              <a:rPr sz="1700" b="0">
+                <a:solidFill>
+                  <a:srgbClr val="1C1C1C"/>
+                </a:solidFill>
+                <a:latin typeface="Calibri"/>
+              </a:rPr>
+              <a:t>1. Menjelaskan tiga istilah itu dengan kata-kata sendiri (bukan hafalan kaku).</a:t>
             </a:r>
           </a:p>
           <a:p>
@@ -9769,13 +9465,13 @@
               </a:spcAft>
             </a:pPr>
             <a:r>
-              <a:rPr sz="1500" b="0">
-                <a:solidFill>
-                  <a:srgbClr val="5A6570"/>
-                </a:solidFill>
-                <a:latin typeface="Calibri"/>
-              </a:rPr>
-              <a:t>1) menjelaskan ketiga konsep dengan bahasa sendiri,</a:t>
+              <a:rPr sz="1700" b="0">
+                <a:solidFill>
+                  <a:srgbClr val="1C1C1C"/>
+                </a:solidFill>
+                <a:latin typeface="Calibri"/>
+              </a:rPr>
+              <a:t>2. Memberi contoh dari kehidupan sehari-hari di kampus atau rumah.</a:t>
             </a:r>
           </a:p>
           <a:p>
@@ -9785,13 +9481,13 @@
               </a:spcAft>
             </a:pPr>
             <a:r>
-              <a:rPr sz="1500" b="0">
-                <a:solidFill>
-                  <a:srgbClr val="5A6570"/>
-                </a:solidFill>
-                <a:latin typeface="Calibri"/>
-              </a:rPr>
-              <a:t>2) memberi contoh konkret untuk masing-masing,</a:t>
+              <a:rPr sz="1700" b="0">
+                <a:solidFill>
+                  <a:srgbClr val="1C1C1C"/>
+                </a:solidFill>
+                <a:latin typeface="Calibri"/>
+              </a:rPr>
+              <a:t>3. Menilai sebuah usaha: “Ini baru jualan biasa, atau sudah pakai teknologi sebagai inti?”</a:t>
             </a:r>
           </a:p>
           <a:p>
@@ -9801,20 +9497,36 @@
               </a:spcAft>
             </a:pPr>
             <a:r>
-              <a:rPr sz="1500" b="0">
-                <a:solidFill>
-                  <a:srgbClr val="5A6570"/>
-                </a:solidFill>
-                <a:latin typeface="Calibri"/>
-              </a:rPr>
-              <a:t>3) menilai apakah suatu usaha termasuk digitalisasi ringan, technopreneur, atau bisnis digital.</a:t>
-            </a:r>
-          </a:p>
-        </p:txBody>
-      </p:sp>
-      <p:sp>
-        <p:nvSpPr>
-          <p:cNvPr id="13" name="TextBox 12"/>
+              <a:rPr sz="1700" b="0">
+                <a:solidFill>
+                  <a:srgbClr val="1C1C1C"/>
+                </a:solidFill>
+                <a:latin typeface="Calibri"/>
+              </a:rPr>
+              <a:t/>
+            </a:r>
+          </a:p>
+          <a:p>
+            <a:pPr algn="l">
+              <a:spcAft>
+                <a:spcPts val="600"/>
+              </a:spcAft>
+            </a:pPr>
+            <a:r>
+              <a:rPr sz="1700" b="0">
+                <a:solidFill>
+                  <a:srgbClr val="1C1C1C"/>
+                </a:solidFill>
+                <a:latin typeface="Calibri"/>
+              </a:rPr>
+              <a:t>Intinya: kita belajar melihat peluang dengan mata manusia, bukan dengan bahasa mesin.</a:t>
+            </a:r>
+          </a:p>
+        </p:txBody>
+      </p:sp>
+      <p:sp>
+        <p:nvSpPr>
+          <p:cNvPr id="9" name="TextBox 8"/>
           <p:cNvSpPr txBox="1"/>
           <p:nvPr/>
         </p:nvSpPr>
@@ -9842,14 +9554,14 @@
                 </a:solidFill>
                 <a:latin typeface="Calibri"/>
               </a:rPr>
-              <a:t>Technopreneurship · S1 Bisnis Digital Sem 3 · Sub-CPMK 1.1</a:t>
-            </a:r>
-          </a:p>
-        </p:txBody>
-      </p:sp>
-      <p:sp>
-        <p:nvSpPr>
-          <p:cNvPr id="14" name="TextBox 13"/>
+              <a:t>Technopreneurship · Bisnis Digital Sem 3 · Sub-CPMK 1.1</a:t>
+            </a:r>
+          </a:p>
+        </p:txBody>
+      </p:sp>
+      <p:sp>
+        <p:nvSpPr>
+          <p:cNvPr id="10" name="TextBox 9"/>
           <p:cNvSpPr txBox="1"/>
           <p:nvPr/>
         </p:nvSpPr>
@@ -10010,13 +9722,13 @@
           <a:p>
             <a:pPr algn="l"/>
             <a:r>
-              <a:rPr sz="2800" b="1">
+              <a:rPr sz="2600" b="1">
                 <a:solidFill>
                   <a:srgbClr val="0F2C4C"/>
                 </a:solidFill>
                 <a:latin typeface="Calibri"/>
               </a:rPr>
-              <a:t>Agenda Pertemuan</a:t>
+              <a:t>Alur belajar kita hari ini</a:t>
             </a:r>
           </a:p>
         </p:txBody>
@@ -10051,7 +9763,7 @@
                 </a:solidFill>
                 <a:latin typeface="Calibri"/>
               </a:rPr>
-              <a:t>Urutan belajar dari dasar</a:t>
+              <a:t>Dari cerita → pengertian → latihan → tugas kecil</a:t>
             </a:r>
           </a:p>
         </p:txBody>
@@ -10064,8 +9776,51 @@
         </p:nvSpPr>
         <p:spPr>
           <a:xfrm>
-            <a:off x="640080" y="1325880"/>
-            <a:ext cx="1005840" cy="502920"/>
+            <a:off x="502920" y="1554480"/>
+            <a:ext cx="2743200" cy="3931920"/>
+          </a:xfrm>
+          <a:prstGeom prst="roundRect">
+            <a:avLst/>
+          </a:prstGeom>
+          <a:solidFill>
+            <a:srgbClr val="FFFFFF"/>
+          </a:solidFill>
+          <a:ln>
+            <a:noFill/>
+          </a:ln>
+        </p:spPr>
+        <p:style>
+          <a:lnRef idx="1">
+            <a:schemeClr val="accent1"/>
+          </a:lnRef>
+          <a:fillRef idx="3">
+            <a:schemeClr val="accent1"/>
+          </a:fillRef>
+          <a:effectRef idx="2">
+            <a:schemeClr val="accent1"/>
+          </a:effectRef>
+          <a:fontRef idx="minor">
+            <a:schemeClr val="lt1"/>
+          </a:fontRef>
+        </p:style>
+        <p:txBody>
+          <a:bodyPr rtlCol="0" anchor="ctr"/>
+          <a:lstStyle/>
+          <a:p>
+            <a:pPr algn="ctr"/>
+          </a:p>
+        </p:txBody>
+      </p:sp>
+      <p:sp>
+        <p:nvSpPr>
+          <p:cNvPr id="7" name="Rounded Rectangle 6"/>
+          <p:cNvSpPr/>
+          <p:nvPr/>
+        </p:nvSpPr>
+        <p:spPr>
+          <a:xfrm>
+            <a:off x="1417320" y="1920240"/>
+            <a:ext cx="914400" cy="914400"/>
           </a:xfrm>
           <a:prstGeom prst="roundRect">
             <a:avLst/>
@@ -10101,14 +9856,14 @@
       </p:sp>
       <p:sp>
         <p:nvSpPr>
-          <p:cNvPr id="7" name="TextBox 6"/>
-          <p:cNvSpPr txBox="1"/>
-          <p:nvPr/>
-        </p:nvSpPr>
-        <p:spPr>
-          <a:xfrm>
-            <a:off x="640080" y="1399032"/>
-            <a:ext cx="1005840" cy="365760"/>
+          <p:cNvPr id="8" name="TextBox 7"/>
+          <p:cNvSpPr txBox="1"/>
+          <p:nvPr/>
+        </p:nvSpPr>
+        <p:spPr>
+          <a:xfrm>
+            <a:off x="1417320" y="2103120"/>
+            <a:ext cx="914400" cy="548640"/>
           </a:xfrm>
           <a:prstGeom prst="rect">
             <a:avLst/>
@@ -10123,27 +9878,97 @@
           <a:p>
             <a:pPr algn="ctr"/>
             <a:r>
-              <a:rPr sz="1800" b="1">
+              <a:rPr sz="2200" b="1">
                 <a:solidFill>
                   <a:srgbClr val="FFFFFF"/>
                 </a:solidFill>
                 <a:latin typeface="Calibri"/>
               </a:rPr>
-              <a:t>01</a:t>
-            </a:r>
-          </a:p>
-        </p:txBody>
-      </p:sp>
-      <p:sp>
-        <p:nvSpPr>
-          <p:cNvPr id="8" name="Rounded Rectangle 7"/>
+              <a:t>1</a:t>
+            </a:r>
+          </a:p>
+        </p:txBody>
+      </p:sp>
+      <p:sp>
+        <p:nvSpPr>
+          <p:cNvPr id="9" name="TextBox 8"/>
+          <p:cNvSpPr txBox="1"/>
+          <p:nvPr/>
+        </p:nvSpPr>
+        <p:spPr>
+          <a:xfrm>
+            <a:off x="685800" y="3200400"/>
+            <a:ext cx="2377440" cy="731520"/>
+          </a:xfrm>
+          <a:prstGeom prst="rect">
+            <a:avLst/>
+          </a:prstGeom>
+          <a:noFill/>
+        </p:spPr>
+        <p:txBody>
+          <a:bodyPr wrap="square">
+            <a:spAutoFit/>
+          </a:bodyPr>
+          <a:lstStyle/>
+          <a:p>
+            <a:pPr algn="ctr"/>
+            <a:r>
+              <a:rPr sz="1700" b="1">
+                <a:solidFill>
+                  <a:srgbClr val="0F2C4C"/>
+                </a:solidFill>
+                <a:latin typeface="Calibri"/>
+              </a:rPr>
+              <a:t>Cerita singkat</a:t>
+            </a:r>
+          </a:p>
+        </p:txBody>
+      </p:sp>
+      <p:sp>
+        <p:nvSpPr>
+          <p:cNvPr id="10" name="TextBox 9"/>
+          <p:cNvSpPr txBox="1"/>
+          <p:nvPr/>
+        </p:nvSpPr>
+        <p:spPr>
+          <a:xfrm>
+            <a:off x="685800" y="4114800"/>
+            <a:ext cx="2377440" cy="1005840"/>
+          </a:xfrm>
+          <a:prstGeom prst="rect">
+            <a:avLst/>
+          </a:prstGeom>
+          <a:noFill/>
+        </p:spPr>
+        <p:txBody>
+          <a:bodyPr wrap="square">
+            <a:spAutoFit/>
+          </a:bodyPr>
+          <a:lstStyle/>
+          <a:p>
+            <a:pPr algn="ctr"/>
+            <a:r>
+              <a:rPr sz="1400" b="0">
+                <a:solidFill>
+                  <a:srgbClr val="5A6570"/>
+                </a:solidFill>
+                <a:latin typeface="Calibri"/>
+              </a:rPr>
+              <a:t>Kenapa tiga istilah ini sering tertukar</a:t>
+            </a:r>
+          </a:p>
+        </p:txBody>
+      </p:sp>
+      <p:sp>
+        <p:nvSpPr>
+          <p:cNvPr id="11" name="Rounded Rectangle 10"/>
           <p:cNvSpPr/>
           <p:nvPr/>
         </p:nvSpPr>
         <p:spPr>
           <a:xfrm>
-            <a:off x="1828800" y="1325880"/>
-            <a:ext cx="9601200" cy="502920"/>
+            <a:off x="3429000" y="1554480"/>
+            <a:ext cx="2743200" cy="3931920"/>
           </a:xfrm>
           <a:prstGeom prst="roundRect">
             <a:avLst/>
@@ -10179,55 +10004,20 @@
       </p:sp>
       <p:sp>
         <p:nvSpPr>
-          <p:cNvPr id="9" name="TextBox 8"/>
-          <p:cNvSpPr txBox="1"/>
-          <p:nvPr/>
-        </p:nvSpPr>
-        <p:spPr>
-          <a:xfrm>
-            <a:off x="2057400" y="1417320"/>
-            <a:ext cx="9144000" cy="365760"/>
-          </a:xfrm>
-          <a:prstGeom prst="rect">
-            <a:avLst/>
-          </a:prstGeom>
-          <a:noFill/>
-        </p:spPr>
-        <p:txBody>
-          <a:bodyPr wrap="square">
-            <a:spAutoFit/>
-          </a:bodyPr>
-          <a:lstStyle/>
-          <a:p>
-            <a:pPr algn="l"/>
-            <a:r>
-              <a:rPr sz="1800" b="0">
-                <a:solidFill>
-                  <a:srgbClr val="1C1C1C"/>
-                </a:solidFill>
-                <a:latin typeface="Calibri"/>
-              </a:rPr>
-              <a:t>Mengapa tiga istilah ini sering tertukar</a:t>
-            </a:r>
-          </a:p>
-        </p:txBody>
-      </p:sp>
-      <p:sp>
-        <p:nvSpPr>
-          <p:cNvPr id="10" name="Rounded Rectangle 9"/>
+          <p:cNvPr id="12" name="Rounded Rectangle 11"/>
           <p:cNvSpPr/>
           <p:nvPr/>
         </p:nvSpPr>
         <p:spPr>
           <a:xfrm>
-            <a:off x="640080" y="2057400"/>
-            <a:ext cx="1005840" cy="502920"/>
+            <a:off x="4343400" y="1920240"/>
+            <a:ext cx="914400" cy="914400"/>
           </a:xfrm>
           <a:prstGeom prst="roundRect">
             <a:avLst/>
           </a:prstGeom>
           <a:solidFill>
-            <a:srgbClr val="0F2C4C"/>
+            <a:srgbClr val="1A6B6B"/>
           </a:solidFill>
           <a:ln>
             <a:noFill/>
@@ -10257,14 +10047,14 @@
       </p:sp>
       <p:sp>
         <p:nvSpPr>
-          <p:cNvPr id="11" name="TextBox 10"/>
-          <p:cNvSpPr txBox="1"/>
-          <p:nvPr/>
-        </p:nvSpPr>
-        <p:spPr>
-          <a:xfrm>
-            <a:off x="640080" y="2130552"/>
-            <a:ext cx="1005840" cy="365760"/>
+          <p:cNvPr id="13" name="TextBox 12"/>
+          <p:cNvSpPr txBox="1"/>
+          <p:nvPr/>
+        </p:nvSpPr>
+        <p:spPr>
+          <a:xfrm>
+            <a:off x="4343400" y="2103120"/>
+            <a:ext cx="914400" cy="548640"/>
           </a:xfrm>
           <a:prstGeom prst="rect">
             <a:avLst/>
@@ -10279,27 +10069,97 @@
           <a:p>
             <a:pPr algn="ctr"/>
             <a:r>
-              <a:rPr sz="1800" b="1">
+              <a:rPr sz="2200" b="1">
                 <a:solidFill>
                   <a:srgbClr val="FFFFFF"/>
                 </a:solidFill>
                 <a:latin typeface="Calibri"/>
               </a:rPr>
-              <a:t>02</a:t>
-            </a:r>
-          </a:p>
-        </p:txBody>
-      </p:sp>
-      <p:sp>
-        <p:nvSpPr>
-          <p:cNvPr id="12" name="Rounded Rectangle 11"/>
+              <a:t>2</a:t>
+            </a:r>
+          </a:p>
+        </p:txBody>
+      </p:sp>
+      <p:sp>
+        <p:nvSpPr>
+          <p:cNvPr id="14" name="TextBox 13"/>
+          <p:cNvSpPr txBox="1"/>
+          <p:nvPr/>
+        </p:nvSpPr>
+        <p:spPr>
+          <a:xfrm>
+            <a:off x="3611880" y="3200400"/>
+            <a:ext cx="2377440" cy="731520"/>
+          </a:xfrm>
+          <a:prstGeom prst="rect">
+            <a:avLst/>
+          </a:prstGeom>
+          <a:noFill/>
+        </p:spPr>
+        <p:txBody>
+          <a:bodyPr wrap="square">
+            <a:spAutoFit/>
+          </a:bodyPr>
+          <a:lstStyle/>
+          <a:p>
+            <a:pPr algn="ctr"/>
+            <a:r>
+              <a:rPr sz="1700" b="1">
+                <a:solidFill>
+                  <a:srgbClr val="0F2C4C"/>
+                </a:solidFill>
+                <a:latin typeface="Calibri"/>
+              </a:rPr>
+              <a:t>Kenalan 3 tokoh</a:t>
+            </a:r>
+          </a:p>
+        </p:txBody>
+      </p:sp>
+      <p:sp>
+        <p:nvSpPr>
+          <p:cNvPr id="15" name="TextBox 14"/>
+          <p:cNvSpPr txBox="1"/>
+          <p:nvPr/>
+        </p:nvSpPr>
+        <p:spPr>
+          <a:xfrm>
+            <a:off x="3611880" y="4114800"/>
+            <a:ext cx="2377440" cy="1005840"/>
+          </a:xfrm>
+          <a:prstGeom prst="rect">
+            <a:avLst/>
+          </a:prstGeom>
+          <a:noFill/>
+        </p:spPr>
+        <p:txBody>
+          <a:bodyPr wrap="square">
+            <a:spAutoFit/>
+          </a:bodyPr>
+          <a:lstStyle/>
+          <a:p>
+            <a:pPr algn="ctr"/>
+            <a:r>
+              <a:rPr sz="1400" b="0">
+                <a:solidFill>
+                  <a:srgbClr val="5A6570"/>
+                </a:solidFill>
+                <a:latin typeface="Calibri"/>
+              </a:rPr>
+              <a:t>Entrepreneur, technopreneur, bisnis digital</a:t>
+            </a:r>
+          </a:p>
+        </p:txBody>
+      </p:sp>
+      <p:sp>
+        <p:nvSpPr>
+          <p:cNvPr id="16" name="Rounded Rectangle 15"/>
           <p:cNvSpPr/>
           <p:nvPr/>
         </p:nvSpPr>
         <p:spPr>
           <a:xfrm>
-            <a:off x="1828800" y="2057400"/>
-            <a:ext cx="9601200" cy="502920"/>
+            <a:off x="6355080" y="1554480"/>
+            <a:ext cx="2743200" cy="3931920"/>
           </a:xfrm>
           <a:prstGeom prst="roundRect">
             <a:avLst/>
@@ -10335,49 +10195,14 @@
       </p:sp>
       <p:sp>
         <p:nvSpPr>
-          <p:cNvPr id="13" name="TextBox 12"/>
-          <p:cNvSpPr txBox="1"/>
-          <p:nvPr/>
-        </p:nvSpPr>
-        <p:spPr>
-          <a:xfrm>
-            <a:off x="2057400" y="2148840"/>
-            <a:ext cx="9144000" cy="365760"/>
-          </a:xfrm>
-          <a:prstGeom prst="rect">
-            <a:avLst/>
-          </a:prstGeom>
-          <a:noFill/>
-        </p:spPr>
-        <p:txBody>
-          <a:bodyPr wrap="square">
-            <a:spAutoFit/>
-          </a:bodyPr>
-          <a:lstStyle/>
-          <a:p>
-            <a:pPr algn="l"/>
-            <a:r>
-              <a:rPr sz="1800" b="0">
-                <a:solidFill>
-                  <a:srgbClr val="1C1C1C"/>
-                </a:solidFill>
-                <a:latin typeface="Calibri"/>
-              </a:rPr>
-              <a:t>Apa itu entrepreneur</a:t>
-            </a:r>
-          </a:p>
-        </p:txBody>
-      </p:sp>
-      <p:sp>
-        <p:nvSpPr>
-          <p:cNvPr id="14" name="Rounded Rectangle 13"/>
+          <p:cNvPr id="17" name="Rounded Rectangle 16"/>
           <p:cNvSpPr/>
           <p:nvPr/>
         </p:nvSpPr>
         <p:spPr>
           <a:xfrm>
-            <a:off x="640080" y="2788920"/>
-            <a:ext cx="1005840" cy="502920"/>
+            <a:off x="7269480" y="1920240"/>
+            <a:ext cx="914400" cy="914400"/>
           </a:xfrm>
           <a:prstGeom prst="roundRect">
             <a:avLst/>
@@ -10413,14 +10238,14 @@
       </p:sp>
       <p:sp>
         <p:nvSpPr>
-          <p:cNvPr id="15" name="TextBox 14"/>
-          <p:cNvSpPr txBox="1"/>
-          <p:nvPr/>
-        </p:nvSpPr>
-        <p:spPr>
-          <a:xfrm>
-            <a:off x="640080" y="2862072"/>
-            <a:ext cx="1005840" cy="365760"/>
+          <p:cNvPr id="18" name="TextBox 17"/>
+          <p:cNvSpPr txBox="1"/>
+          <p:nvPr/>
+        </p:nvSpPr>
+        <p:spPr>
+          <a:xfrm>
+            <a:off x="7269480" y="2103120"/>
+            <a:ext cx="914400" cy="548640"/>
           </a:xfrm>
           <a:prstGeom prst="rect">
             <a:avLst/>
@@ -10435,27 +10260,97 @@
           <a:p>
             <a:pPr algn="ctr"/>
             <a:r>
-              <a:rPr sz="1800" b="1">
+              <a:rPr sz="2200" b="1">
                 <a:solidFill>
                   <a:srgbClr val="FFFFFF"/>
                 </a:solidFill>
                 <a:latin typeface="Calibri"/>
               </a:rPr>
-              <a:t>03</a:t>
-            </a:r>
-          </a:p>
-        </p:txBody>
-      </p:sp>
-      <p:sp>
-        <p:nvSpPr>
-          <p:cNvPr id="16" name="Rounded Rectangle 15"/>
+              <a:t>3</a:t>
+            </a:r>
+          </a:p>
+        </p:txBody>
+      </p:sp>
+      <p:sp>
+        <p:nvSpPr>
+          <p:cNvPr id="19" name="TextBox 18"/>
+          <p:cNvSpPr txBox="1"/>
+          <p:nvPr/>
+        </p:nvSpPr>
+        <p:spPr>
+          <a:xfrm>
+            <a:off x="6537960" y="3200400"/>
+            <a:ext cx="2377440" cy="731520"/>
+          </a:xfrm>
+          <a:prstGeom prst="rect">
+            <a:avLst/>
+          </a:prstGeom>
+          <a:noFill/>
+        </p:spPr>
+        <p:txBody>
+          <a:bodyPr wrap="square">
+            <a:spAutoFit/>
+          </a:bodyPr>
+          <a:lstStyle/>
+          <a:p>
+            <a:pPr algn="ctr"/>
+            <a:r>
+              <a:rPr sz="1700" b="1">
+                <a:solidFill>
+                  <a:srgbClr val="0F2C4C"/>
+                </a:solidFill>
+                <a:latin typeface="Calibri"/>
+              </a:rPr>
+              <a:t>Bandingkan</a:t>
+            </a:r>
+          </a:p>
+        </p:txBody>
+      </p:sp>
+      <p:sp>
+        <p:nvSpPr>
+          <p:cNvPr id="20" name="TextBox 19"/>
+          <p:cNvSpPr txBox="1"/>
+          <p:nvPr/>
+        </p:nvSpPr>
+        <p:spPr>
+          <a:xfrm>
+            <a:off x="6537960" y="4114800"/>
+            <a:ext cx="2377440" cy="1005840"/>
+          </a:xfrm>
+          <a:prstGeom prst="rect">
+            <a:avLst/>
+          </a:prstGeom>
+          <a:noFill/>
+        </p:spPr>
+        <p:txBody>
+          <a:bodyPr wrap="square">
+            <a:spAutoFit/>
+          </a:bodyPr>
+          <a:lstStyle/>
+          <a:p>
+            <a:pPr algn="ctr"/>
+            <a:r>
+              <a:rPr sz="1400" b="0">
+                <a:solidFill>
+                  <a:srgbClr val="5A6570"/>
+                </a:solidFill>
+                <a:latin typeface="Calibri"/>
+              </a:rPr>
+              <a:t>Tabel sederhana + contoh Indonesia</a:t>
+            </a:r>
+          </a:p>
+        </p:txBody>
+      </p:sp>
+      <p:sp>
+        <p:nvSpPr>
+          <p:cNvPr id="21" name="Rounded Rectangle 20"/>
           <p:cNvSpPr/>
           <p:nvPr/>
         </p:nvSpPr>
         <p:spPr>
           <a:xfrm>
-            <a:off x="1828800" y="2788920"/>
-            <a:ext cx="9601200" cy="502920"/>
+            <a:off x="9281160" y="1554480"/>
+            <a:ext cx="2743200" cy="3931920"/>
           </a:xfrm>
           <a:prstGeom prst="roundRect">
             <a:avLst/>
@@ -10491,205 +10386,14 @@
       </p:sp>
       <p:sp>
         <p:nvSpPr>
-          <p:cNvPr id="17" name="TextBox 16"/>
-          <p:cNvSpPr txBox="1"/>
-          <p:nvPr/>
-        </p:nvSpPr>
-        <p:spPr>
-          <a:xfrm>
-            <a:off x="2057400" y="2880360"/>
-            <a:ext cx="9144000" cy="365760"/>
-          </a:xfrm>
-          <a:prstGeom prst="rect">
-            <a:avLst/>
-          </a:prstGeom>
-          <a:noFill/>
-        </p:spPr>
-        <p:txBody>
-          <a:bodyPr wrap="square">
-            <a:spAutoFit/>
-          </a:bodyPr>
-          <a:lstStyle/>
-          <a:p>
-            <a:pPr algn="l"/>
-            <a:r>
-              <a:rPr sz="1800" b="0">
-                <a:solidFill>
-                  <a:srgbClr val="1C1C1C"/>
-                </a:solidFill>
-                <a:latin typeface="Calibri"/>
-              </a:rPr>
-              <a:t>Apa itu technopreneur</a:t>
-            </a:r>
-          </a:p>
-        </p:txBody>
-      </p:sp>
-      <p:sp>
-        <p:nvSpPr>
-          <p:cNvPr id="18" name="Rounded Rectangle 17"/>
-          <p:cNvSpPr/>
-          <p:nvPr/>
-        </p:nvSpPr>
-        <p:spPr>
-          <a:xfrm>
-            <a:off x="640080" y="3520440"/>
-            <a:ext cx="1005840" cy="502920"/>
-          </a:xfrm>
-          <a:prstGeom prst="roundRect">
-            <a:avLst/>
-          </a:prstGeom>
-          <a:solidFill>
-            <a:srgbClr val="0F2C4C"/>
-          </a:solidFill>
-          <a:ln>
-            <a:noFill/>
-          </a:ln>
-        </p:spPr>
-        <p:style>
-          <a:lnRef idx="1">
-            <a:schemeClr val="accent1"/>
-          </a:lnRef>
-          <a:fillRef idx="3">
-            <a:schemeClr val="accent1"/>
-          </a:fillRef>
-          <a:effectRef idx="2">
-            <a:schemeClr val="accent1"/>
-          </a:effectRef>
-          <a:fontRef idx="minor">
-            <a:schemeClr val="lt1"/>
-          </a:fontRef>
-        </p:style>
-        <p:txBody>
-          <a:bodyPr rtlCol="0" anchor="ctr"/>
-          <a:lstStyle/>
-          <a:p>
-            <a:pPr algn="ctr"/>
-          </a:p>
-        </p:txBody>
-      </p:sp>
-      <p:sp>
-        <p:nvSpPr>
-          <p:cNvPr id="19" name="TextBox 18"/>
-          <p:cNvSpPr txBox="1"/>
-          <p:nvPr/>
-        </p:nvSpPr>
-        <p:spPr>
-          <a:xfrm>
-            <a:off x="640080" y="3593592"/>
-            <a:ext cx="1005840" cy="365760"/>
-          </a:xfrm>
-          <a:prstGeom prst="rect">
-            <a:avLst/>
-          </a:prstGeom>
-          <a:noFill/>
-        </p:spPr>
-        <p:txBody>
-          <a:bodyPr wrap="square">
-            <a:spAutoFit/>
-          </a:bodyPr>
-          <a:lstStyle/>
-          <a:p>
-            <a:pPr algn="ctr"/>
-            <a:r>
-              <a:rPr sz="1800" b="1">
-                <a:solidFill>
-                  <a:srgbClr val="FFFFFF"/>
-                </a:solidFill>
-                <a:latin typeface="Calibri"/>
-              </a:rPr>
-              <a:t>04</a:t>
-            </a:r>
-          </a:p>
-        </p:txBody>
-      </p:sp>
-      <p:sp>
-        <p:nvSpPr>
-          <p:cNvPr id="20" name="Rounded Rectangle 19"/>
-          <p:cNvSpPr/>
-          <p:nvPr/>
-        </p:nvSpPr>
-        <p:spPr>
-          <a:xfrm>
-            <a:off x="1828800" y="3520440"/>
-            <a:ext cx="9601200" cy="502920"/>
-          </a:xfrm>
-          <a:prstGeom prst="roundRect">
-            <a:avLst/>
-          </a:prstGeom>
-          <a:solidFill>
-            <a:srgbClr val="FFFFFF"/>
-          </a:solidFill>
-          <a:ln>
-            <a:noFill/>
-          </a:ln>
-        </p:spPr>
-        <p:style>
-          <a:lnRef idx="1">
-            <a:schemeClr val="accent1"/>
-          </a:lnRef>
-          <a:fillRef idx="3">
-            <a:schemeClr val="accent1"/>
-          </a:fillRef>
-          <a:effectRef idx="2">
-            <a:schemeClr val="accent1"/>
-          </a:effectRef>
-          <a:fontRef idx="minor">
-            <a:schemeClr val="lt1"/>
-          </a:fontRef>
-        </p:style>
-        <p:txBody>
-          <a:bodyPr rtlCol="0" anchor="ctr"/>
-          <a:lstStyle/>
-          <a:p>
-            <a:pPr algn="ctr"/>
-          </a:p>
-        </p:txBody>
-      </p:sp>
-      <p:sp>
-        <p:nvSpPr>
-          <p:cNvPr id="21" name="TextBox 20"/>
-          <p:cNvSpPr txBox="1"/>
-          <p:nvPr/>
-        </p:nvSpPr>
-        <p:spPr>
-          <a:xfrm>
-            <a:off x="2057400" y="3611880"/>
-            <a:ext cx="9144000" cy="365760"/>
-          </a:xfrm>
-          <a:prstGeom prst="rect">
-            <a:avLst/>
-          </a:prstGeom>
-          <a:noFill/>
-        </p:spPr>
-        <p:txBody>
-          <a:bodyPr wrap="square">
-            <a:spAutoFit/>
-          </a:bodyPr>
-          <a:lstStyle/>
-          <a:p>
-            <a:pPr algn="l"/>
-            <a:r>
-              <a:rPr sz="1800" b="0">
-                <a:solidFill>
-                  <a:srgbClr val="1C1C1C"/>
-                </a:solidFill>
-                <a:latin typeface="Calibri"/>
-              </a:rPr>
-              <a:t>Apa itu bisnis digital</a:t>
-            </a:r>
-          </a:p>
-        </p:txBody>
-      </p:sp>
-      <p:sp>
-        <p:nvSpPr>
           <p:cNvPr id="22" name="Rounded Rectangle 21"/>
           <p:cNvSpPr/>
           <p:nvPr/>
         </p:nvSpPr>
         <p:spPr>
           <a:xfrm>
-            <a:off x="640080" y="4251960"/>
-            <a:ext cx="1005840" cy="502920"/>
+            <a:off x="10195560" y="1920240"/>
+            <a:ext cx="914400" cy="914400"/>
           </a:xfrm>
           <a:prstGeom prst="roundRect">
             <a:avLst/>
@@ -10731,8 +10435,8 @@
         </p:nvSpPr>
         <p:spPr>
           <a:xfrm>
-            <a:off x="640080" y="4325112"/>
-            <a:ext cx="1005840" cy="365760"/>
+            <a:off x="10195560" y="2103120"/>
+            <a:ext cx="914400" cy="548640"/>
           </a:xfrm>
           <a:prstGeom prst="rect">
             <a:avLst/>
@@ -10747,57 +10451,49 @@
           <a:p>
             <a:pPr algn="ctr"/>
             <a:r>
-              <a:rPr sz="1800" b="1">
+              <a:rPr sz="2200" b="1">
                 <a:solidFill>
                   <a:srgbClr val="FFFFFF"/>
                 </a:solidFill>
                 <a:latin typeface="Calibri"/>
               </a:rPr>
-              <a:t>05</a:t>
-            </a:r>
-          </a:p>
-        </p:txBody>
-      </p:sp>
-      <p:sp>
-        <p:nvSpPr>
-          <p:cNvPr id="24" name="Rounded Rectangle 23"/>
-          <p:cNvSpPr/>
-          <p:nvPr/>
-        </p:nvSpPr>
-        <p:spPr>
-          <a:xfrm>
-            <a:off x="1828800" y="4251960"/>
-            <a:ext cx="9601200" cy="502920"/>
-          </a:xfrm>
-          <a:prstGeom prst="roundRect">
-            <a:avLst/>
-          </a:prstGeom>
-          <a:solidFill>
-            <a:srgbClr val="FFFFFF"/>
-          </a:solidFill>
-          <a:ln>
-            <a:noFill/>
-          </a:ln>
-        </p:spPr>
-        <p:style>
-          <a:lnRef idx="1">
-            <a:schemeClr val="accent1"/>
-          </a:lnRef>
-          <a:fillRef idx="3">
-            <a:schemeClr val="accent1"/>
-          </a:fillRef>
-          <a:effectRef idx="2">
-            <a:schemeClr val="accent1"/>
-          </a:effectRef>
-          <a:fontRef idx="minor">
-            <a:schemeClr val="lt1"/>
-          </a:fontRef>
-        </p:style>
-        <p:txBody>
-          <a:bodyPr rtlCol="0" anchor="ctr"/>
+              <a:t>4</a:t>
+            </a:r>
+          </a:p>
+        </p:txBody>
+      </p:sp>
+      <p:sp>
+        <p:nvSpPr>
+          <p:cNvPr id="24" name="TextBox 23"/>
+          <p:cNvSpPr txBox="1"/>
+          <p:nvPr/>
+        </p:nvSpPr>
+        <p:spPr>
+          <a:xfrm>
+            <a:off x="9464040" y="3200400"/>
+            <a:ext cx="2377440" cy="731520"/>
+          </a:xfrm>
+          <a:prstGeom prst="rect">
+            <a:avLst/>
+          </a:prstGeom>
+          <a:noFill/>
+        </p:spPr>
+        <p:txBody>
+          <a:bodyPr wrap="square">
+            <a:spAutoFit/>
+          </a:bodyPr>
           <a:lstStyle/>
           <a:p>
             <a:pPr algn="ctr"/>
+            <a:r>
+              <a:rPr sz="1700" b="1">
+                <a:solidFill>
+                  <a:srgbClr val="0F2C4C"/>
+                </a:solidFill>
+                <a:latin typeface="Calibri"/>
+              </a:rPr>
+              <a:t>Latihan</a:t>
+            </a:r>
           </a:p>
         </p:txBody>
       </p:sp>
@@ -10809,192 +10505,36 @@
         </p:nvSpPr>
         <p:spPr>
           <a:xfrm>
-            <a:off x="2057400" y="4343400"/>
-            <a:ext cx="9144000" cy="365760"/>
-          </a:xfrm>
-          <a:prstGeom prst="rect">
-            <a:avLst/>
-          </a:prstGeom>
-          <a:noFill/>
-        </p:spPr>
-        <p:txBody>
-          <a:bodyPr wrap="square">
-            <a:spAutoFit/>
-          </a:bodyPr>
-          <a:lstStyle/>
-          <a:p>
-            <a:pPr algn="l"/>
-            <a:r>
-              <a:rPr sz="1800" b="0">
-                <a:solidFill>
-                  <a:srgbClr val="1C1C1C"/>
-                </a:solidFill>
-                <a:latin typeface="Calibri"/>
-              </a:rPr>
-              <a:t>Tabel pembeda + contoh Indonesia</a:t>
-            </a:r>
-          </a:p>
-        </p:txBody>
-      </p:sp>
-      <p:sp>
-        <p:nvSpPr>
-          <p:cNvPr id="26" name="Rounded Rectangle 25"/>
-          <p:cNvSpPr/>
-          <p:nvPr/>
-        </p:nvSpPr>
-        <p:spPr>
-          <a:xfrm>
-            <a:off x="640080" y="4983480"/>
-            <a:ext cx="1005840" cy="502920"/>
-          </a:xfrm>
-          <a:prstGeom prst="roundRect">
-            <a:avLst/>
-          </a:prstGeom>
-          <a:solidFill>
-            <a:srgbClr val="0F2C4C"/>
-          </a:solidFill>
-          <a:ln>
-            <a:noFill/>
-          </a:ln>
-        </p:spPr>
-        <p:style>
-          <a:lnRef idx="1">
-            <a:schemeClr val="accent1"/>
-          </a:lnRef>
-          <a:fillRef idx="3">
-            <a:schemeClr val="accent1"/>
-          </a:fillRef>
-          <a:effectRef idx="2">
-            <a:schemeClr val="accent1"/>
-          </a:effectRef>
-          <a:fontRef idx="minor">
-            <a:schemeClr val="lt1"/>
-          </a:fontRef>
-        </p:style>
-        <p:txBody>
-          <a:bodyPr rtlCol="0" anchor="ctr"/>
+            <a:off x="9464040" y="4114800"/>
+            <a:ext cx="2377440" cy="1005840"/>
+          </a:xfrm>
+          <a:prstGeom prst="rect">
+            <a:avLst/>
+          </a:prstGeom>
+          <a:noFill/>
+        </p:spPr>
+        <p:txBody>
+          <a:bodyPr wrap="square">
+            <a:spAutoFit/>
+          </a:bodyPr>
           <a:lstStyle/>
           <a:p>
             <a:pPr algn="ctr"/>
-          </a:p>
-        </p:txBody>
-      </p:sp>
-      <p:sp>
-        <p:nvSpPr>
-          <p:cNvPr id="27" name="TextBox 26"/>
-          <p:cNvSpPr txBox="1"/>
-          <p:nvPr/>
-        </p:nvSpPr>
-        <p:spPr>
-          <a:xfrm>
-            <a:off x="640080" y="5056632"/>
-            <a:ext cx="1005840" cy="365760"/>
-          </a:xfrm>
-          <a:prstGeom prst="rect">
-            <a:avLst/>
-          </a:prstGeom>
-          <a:noFill/>
-        </p:spPr>
-        <p:txBody>
-          <a:bodyPr wrap="square">
-            <a:spAutoFit/>
-          </a:bodyPr>
-          <a:lstStyle/>
-          <a:p>
-            <a:pPr algn="ctr"/>
-            <a:r>
-              <a:rPr sz="1800" b="1">
-                <a:solidFill>
-                  <a:srgbClr val="FFFFFF"/>
-                </a:solidFill>
-                <a:latin typeface="Calibri"/>
-              </a:rPr>
-              <a:t>06</a:t>
-            </a:r>
-          </a:p>
-        </p:txBody>
-      </p:sp>
-      <p:sp>
-        <p:nvSpPr>
-          <p:cNvPr id="28" name="Rounded Rectangle 27"/>
-          <p:cNvSpPr/>
-          <p:nvPr/>
-        </p:nvSpPr>
-        <p:spPr>
-          <a:xfrm>
-            <a:off x="1828800" y="4983480"/>
-            <a:ext cx="9601200" cy="502920"/>
-          </a:xfrm>
-          <a:prstGeom prst="roundRect">
-            <a:avLst/>
-          </a:prstGeom>
-          <a:solidFill>
-            <a:srgbClr val="FFFFFF"/>
-          </a:solidFill>
-          <a:ln>
-            <a:noFill/>
-          </a:ln>
-        </p:spPr>
-        <p:style>
-          <a:lnRef idx="1">
-            <a:schemeClr val="accent1"/>
-          </a:lnRef>
-          <a:fillRef idx="3">
-            <a:schemeClr val="accent1"/>
-          </a:fillRef>
-          <a:effectRef idx="2">
-            <a:schemeClr val="accent1"/>
-          </a:effectRef>
-          <a:fontRef idx="minor">
-            <a:schemeClr val="lt1"/>
-          </a:fontRef>
-        </p:style>
-        <p:txBody>
-          <a:bodyPr rtlCol="0" anchor="ctr"/>
-          <a:lstStyle/>
-          <a:p>
-            <a:pPr algn="ctr"/>
-          </a:p>
-        </p:txBody>
-      </p:sp>
-      <p:sp>
-        <p:nvSpPr>
-          <p:cNvPr id="29" name="TextBox 28"/>
-          <p:cNvSpPr txBox="1"/>
-          <p:nvPr/>
-        </p:nvSpPr>
-        <p:spPr>
-          <a:xfrm>
-            <a:off x="2057400" y="5074920"/>
-            <a:ext cx="9144000" cy="365760"/>
-          </a:xfrm>
-          <a:prstGeom prst="rect">
-            <a:avLst/>
-          </a:prstGeom>
-          <a:noFill/>
-        </p:spPr>
-        <p:txBody>
-          <a:bodyPr wrap="square">
-            <a:spAutoFit/>
-          </a:bodyPr>
-          <a:lstStyle/>
-          <a:p>
-            <a:pPr algn="l"/>
-            <a:r>
-              <a:rPr sz="1800" b="0">
-                <a:solidFill>
-                  <a:srgbClr val="1C1C1C"/>
-                </a:solidFill>
-                <a:latin typeface="Calibri"/>
-              </a:rPr>
-              <a:t>Cek pemahaman + aktivitas + tugas</a:t>
-            </a:r>
-          </a:p>
-        </p:txBody>
-      </p:sp>
-      <p:sp>
-        <p:nvSpPr>
-          <p:cNvPr id="30" name="TextBox 29"/>
+            <a:r>
+              <a:rPr sz="1400" b="0">
+                <a:solidFill>
+                  <a:srgbClr val="5A6570"/>
+                </a:solidFill>
+                <a:latin typeface="Calibri"/>
+              </a:rPr>
+              <a:t>Coba bedakan usaha di sekitar kampus</a:t>
+            </a:r>
+          </a:p>
+        </p:txBody>
+      </p:sp>
+      <p:sp>
+        <p:nvSpPr>
+          <p:cNvPr id="26" name="TextBox 25"/>
           <p:cNvSpPr txBox="1"/>
           <p:nvPr/>
         </p:nvSpPr>
@@ -11022,14 +10562,14 @@
                 </a:solidFill>
                 <a:latin typeface="Calibri"/>
               </a:rPr>
-              <a:t>Technopreneurship · S1 Bisnis Digital Sem 3 · Sub-CPMK 1.1</a:t>
-            </a:r>
-          </a:p>
-        </p:txBody>
-      </p:sp>
-      <p:sp>
-        <p:nvSpPr>
-          <p:cNvPr id="31" name="TextBox 30"/>
+              <a:t>Technopreneurship · Bisnis Digital Sem 3 · Sub-CPMK 1.1</a:t>
+            </a:r>
+          </a:p>
+        </p:txBody>
+      </p:sp>
+      <p:sp>
+        <p:nvSpPr>
+          <p:cNvPr id="27" name="TextBox 26"/>
           <p:cNvSpPr txBox="1"/>
           <p:nvPr/>
         </p:nvSpPr>
@@ -11190,13 +10730,13 @@
           <a:p>
             <a:pPr algn="l"/>
             <a:r>
-              <a:rPr sz="2800" b="1">
+              <a:rPr sz="2600" b="1">
                 <a:solidFill>
                   <a:srgbClr val="0F2C4C"/>
                 </a:solidFill>
                 <a:latin typeface="Calibri"/>
               </a:rPr>
-              <a:t>Ingat dulu: usaha dimulai dari masalah</a:t>
+              <a:t>Mulai dari yang dekat: masalah orang</a:t>
             </a:r>
           </a:p>
         </p:txBody>
@@ -11231,7 +10771,7 @@
                 </a:solidFill>
                 <a:latin typeface="Calibri"/>
               </a:rPr>
-              <a:t>Pijakan sebelum membedakan istilah</a:t>
+              <a:t>Usaha yang baik lahir dari kepedulian, bukan dari kata-kata rumit</a:t>
             </a:r>
           </a:p>
         </p:txBody>
@@ -11245,7 +10785,7 @@
         <p:spPr>
           <a:xfrm>
             <a:off x="548640" y="1371600"/>
-            <a:ext cx="11064240" cy="1188720"/>
+            <a:ext cx="11064240" cy="1280160"/>
           </a:xfrm>
           <a:prstGeom prst="roundRect">
             <a:avLst/>
@@ -11288,7 +10828,7 @@
         <p:spPr>
           <a:xfrm>
             <a:off x="868680" y="1691640"/>
-            <a:ext cx="10424160" cy="640080"/>
+            <a:ext cx="10424160" cy="731520"/>
           </a:xfrm>
           <a:prstGeom prst="rect">
             <a:avLst/>
@@ -11303,13 +10843,13 @@
           <a:p>
             <a:pPr algn="l"/>
             <a:r>
-              <a:rPr sz="2000" b="1">
+              <a:rPr sz="1800" b="1">
                 <a:solidFill>
                   <a:srgbClr val="FFFFFF"/>
                 </a:solidFill>
                 <a:latin typeface="Calibri"/>
               </a:rPr>
-              <a:t>Jangan mulai dari “ingin jual aplikasi”. Mulai dari: masalah siapa yang ingin diselesaikan?</a:t>
+              <a:t>Bayangkan teman Anda antre 30 menit di kantin. Itu bukan “data”. Itu orang yang lelah dan lapar.</a:t>
             </a:r>
           </a:p>
         </p:txBody>
@@ -11322,7 +10862,7 @@
         </p:nvSpPr>
         <p:spPr>
           <a:xfrm>
-            <a:off x="548640" y="2926080"/>
+            <a:off x="548640" y="3017520"/>
             <a:ext cx="3566160" cy="2286000"/>
           </a:xfrm>
           <a:prstGeom prst="roundRect">
@@ -11359,126 +10899,83 @@
       </p:sp>
       <p:sp>
         <p:nvSpPr>
-          <p:cNvPr id="9" name="Rectangle 8"/>
+          <p:cNvPr id="9" name="TextBox 8"/>
+          <p:cNvSpPr txBox="1"/>
+          <p:nvPr/>
+        </p:nvSpPr>
+        <p:spPr>
+          <a:xfrm>
+            <a:off x="777240" y="3291840"/>
+            <a:ext cx="3108960" cy="457200"/>
+          </a:xfrm>
+          <a:prstGeom prst="rect">
+            <a:avLst/>
+          </a:prstGeom>
+          <a:noFill/>
+        </p:spPr>
+        <p:txBody>
+          <a:bodyPr wrap="square">
+            <a:spAutoFit/>
+          </a:bodyPr>
+          <a:lstStyle/>
+          <a:p>
+            <a:pPr algn="l"/>
+            <a:r>
+              <a:rPr sz="1800" b="1">
+                <a:solidFill>
+                  <a:srgbClr val="0F2C4C"/>
+                </a:solidFill>
+                <a:latin typeface="Calibri"/>
+              </a:rPr>
+              <a:t>Ada yang kesulitan</a:t>
+            </a:r>
+          </a:p>
+        </p:txBody>
+      </p:sp>
+      <p:sp>
+        <p:nvSpPr>
+          <p:cNvPr id="10" name="TextBox 9"/>
+          <p:cNvSpPr txBox="1"/>
+          <p:nvPr/>
+        </p:nvSpPr>
+        <p:spPr>
+          <a:xfrm>
+            <a:off x="777240" y="4023360"/>
+            <a:ext cx="3108960" cy="914400"/>
+          </a:xfrm>
+          <a:prstGeom prst="rect">
+            <a:avLst/>
+          </a:prstGeom>
+          <a:noFill/>
+        </p:spPr>
+        <p:txBody>
+          <a:bodyPr wrap="square">
+            <a:spAutoFit/>
+          </a:bodyPr>
+          <a:lstStyle/>
+          <a:p>
+            <a:pPr algn="l"/>
+            <a:r>
+              <a:rPr sz="1600" b="0">
+                <a:solidFill>
+                  <a:srgbClr val="5A6570"/>
+                </a:solidFill>
+                <a:latin typeface="Calibri"/>
+              </a:rPr>
+              <a:t>Siapa yang mengeluh? Kapan?</a:t>
+            </a:r>
+          </a:p>
+        </p:txBody>
+      </p:sp>
+      <p:sp>
+        <p:nvSpPr>
+          <p:cNvPr id="11" name="Rounded Rectangle 10"/>
           <p:cNvSpPr/>
           <p:nvPr/>
         </p:nvSpPr>
         <p:spPr>
           <a:xfrm>
-            <a:off x="548640" y="2926080"/>
-            <a:ext cx="3566160" cy="109728"/>
-          </a:xfrm>
-          <a:prstGeom prst="rect">
-            <a:avLst/>
-          </a:prstGeom>
-          <a:solidFill>
-            <a:srgbClr val="D97B2A"/>
-          </a:solidFill>
-          <a:ln>
-            <a:noFill/>
-          </a:ln>
-        </p:spPr>
-        <p:style>
-          <a:lnRef idx="1">
-            <a:schemeClr val="accent1"/>
-          </a:lnRef>
-          <a:fillRef idx="3">
-            <a:schemeClr val="accent1"/>
-          </a:fillRef>
-          <a:effectRef idx="2">
-            <a:schemeClr val="accent1"/>
-          </a:effectRef>
-          <a:fontRef idx="minor">
-            <a:schemeClr val="lt1"/>
-          </a:fontRef>
-        </p:style>
-        <p:txBody>
-          <a:bodyPr rtlCol="0" anchor="ctr"/>
-          <a:lstStyle/>
-          <a:p>
-            <a:pPr algn="ctr"/>
-          </a:p>
-        </p:txBody>
-      </p:sp>
-      <p:sp>
-        <p:nvSpPr>
-          <p:cNvPr id="10" name="TextBox 9"/>
-          <p:cNvSpPr txBox="1"/>
-          <p:nvPr/>
-        </p:nvSpPr>
-        <p:spPr>
-          <a:xfrm>
-            <a:off x="777240" y="3246120"/>
-            <a:ext cx="3108960" cy="457200"/>
-          </a:xfrm>
-          <a:prstGeom prst="rect">
-            <a:avLst/>
-          </a:prstGeom>
-          <a:noFill/>
-        </p:spPr>
-        <p:txBody>
-          <a:bodyPr wrap="square">
-            <a:spAutoFit/>
-          </a:bodyPr>
-          <a:lstStyle/>
-          <a:p>
-            <a:pPr algn="l"/>
-            <a:r>
-              <a:rPr sz="2000" b="1">
-                <a:solidFill>
-                  <a:srgbClr val="0F2C4C"/>
-                </a:solidFill>
-                <a:latin typeface="Calibri"/>
-              </a:rPr>
-              <a:t>Masalah nyata</a:t>
-            </a:r>
-          </a:p>
-        </p:txBody>
-      </p:sp>
-      <p:sp>
-        <p:nvSpPr>
-          <p:cNvPr id="11" name="TextBox 10"/>
-          <p:cNvSpPr txBox="1"/>
-          <p:nvPr/>
-        </p:nvSpPr>
-        <p:spPr>
-          <a:xfrm>
-            <a:off x="777240" y="3886200"/>
-            <a:ext cx="3108960" cy="1097280"/>
-          </a:xfrm>
-          <a:prstGeom prst="rect">
-            <a:avLst/>
-          </a:prstGeom>
-          <a:noFill/>
-        </p:spPr>
-        <p:txBody>
-          <a:bodyPr wrap="square">
-            <a:spAutoFit/>
-          </a:bodyPr>
-          <a:lstStyle/>
-          <a:p>
-            <a:pPr algn="l"/>
-            <a:r>
-              <a:rPr sz="1600" b="0">
-                <a:solidFill>
-                  <a:srgbClr val="5A6570"/>
-                </a:solidFill>
-                <a:latin typeface="Calibri"/>
-              </a:rPr>
-              <a:t>Ada keluhan yang berulang di sekitar kita</a:t>
-            </a:r>
-          </a:p>
-        </p:txBody>
-      </p:sp>
-      <p:sp>
-        <p:nvSpPr>
-          <p:cNvPr id="12" name="Rounded Rectangle 11"/>
-          <p:cNvSpPr/>
-          <p:nvPr/>
-        </p:nvSpPr>
-        <p:spPr>
-          <a:xfrm>
-            <a:off x="4343400" y="2926080"/>
+            <a:off x="4343400" y="3017520"/>
             <a:ext cx="3566160" cy="2286000"/>
           </a:xfrm>
           <a:prstGeom prst="roundRect">
@@ -11515,126 +11012,83 @@
       </p:sp>
       <p:sp>
         <p:nvSpPr>
-          <p:cNvPr id="13" name="Rectangle 12"/>
+          <p:cNvPr id="12" name="TextBox 11"/>
+          <p:cNvSpPr txBox="1"/>
+          <p:nvPr/>
+        </p:nvSpPr>
+        <p:spPr>
+          <a:xfrm>
+            <a:off x="4572000" y="3291840"/>
+            <a:ext cx="3108960" cy="457200"/>
+          </a:xfrm>
+          <a:prstGeom prst="rect">
+            <a:avLst/>
+          </a:prstGeom>
+          <a:noFill/>
+        </p:spPr>
+        <p:txBody>
+          <a:bodyPr wrap="square">
+            <a:spAutoFit/>
+          </a:bodyPr>
+          <a:lstStyle/>
+          <a:p>
+            <a:pPr algn="l"/>
+            <a:r>
+              <a:rPr sz="1800" b="1">
+                <a:solidFill>
+                  <a:srgbClr val="0F2C4C"/>
+                </a:solidFill>
+                <a:latin typeface="Calibri"/>
+              </a:rPr>
+              <a:t>Kita peduli</a:t>
+            </a:r>
+          </a:p>
+        </p:txBody>
+      </p:sp>
+      <p:sp>
+        <p:nvSpPr>
+          <p:cNvPr id="13" name="TextBox 12"/>
+          <p:cNvSpPr txBox="1"/>
+          <p:nvPr/>
+        </p:nvSpPr>
+        <p:spPr>
+          <a:xfrm>
+            <a:off x="4572000" y="4023360"/>
+            <a:ext cx="3108960" cy="914400"/>
+          </a:xfrm>
+          <a:prstGeom prst="rect">
+            <a:avLst/>
+          </a:prstGeom>
+          <a:noFill/>
+        </p:spPr>
+        <p:txBody>
+          <a:bodyPr wrap="square">
+            <a:spAutoFit/>
+          </a:bodyPr>
+          <a:lstStyle/>
+          <a:p>
+            <a:pPr algn="l"/>
+            <a:r>
+              <a:rPr sz="1600" b="0">
+                <a:solidFill>
+                  <a:srgbClr val="5A6570"/>
+                </a:solidFill>
+                <a:latin typeface="Calibri"/>
+              </a:rPr>
+              <a:t>Maukah kita bantu?</a:t>
+            </a:r>
+          </a:p>
+        </p:txBody>
+      </p:sp>
+      <p:sp>
+        <p:nvSpPr>
+          <p:cNvPr id="14" name="Rounded Rectangle 13"/>
           <p:cNvSpPr/>
           <p:nvPr/>
         </p:nvSpPr>
         <p:spPr>
           <a:xfrm>
-            <a:off x="4343400" y="2926080"/>
-            <a:ext cx="3566160" cy="109728"/>
-          </a:xfrm>
-          <a:prstGeom prst="rect">
-            <a:avLst/>
-          </a:prstGeom>
-          <a:solidFill>
-            <a:srgbClr val="1A6B6B"/>
-          </a:solidFill>
-          <a:ln>
-            <a:noFill/>
-          </a:ln>
-        </p:spPr>
-        <p:style>
-          <a:lnRef idx="1">
-            <a:schemeClr val="accent1"/>
-          </a:lnRef>
-          <a:fillRef idx="3">
-            <a:schemeClr val="accent1"/>
-          </a:fillRef>
-          <a:effectRef idx="2">
-            <a:schemeClr val="accent1"/>
-          </a:effectRef>
-          <a:fontRef idx="minor">
-            <a:schemeClr val="lt1"/>
-          </a:fontRef>
-        </p:style>
-        <p:txBody>
-          <a:bodyPr rtlCol="0" anchor="ctr"/>
-          <a:lstStyle/>
-          <a:p>
-            <a:pPr algn="ctr"/>
-          </a:p>
-        </p:txBody>
-      </p:sp>
-      <p:sp>
-        <p:nvSpPr>
-          <p:cNvPr id="14" name="TextBox 13"/>
-          <p:cNvSpPr txBox="1"/>
-          <p:nvPr/>
-        </p:nvSpPr>
-        <p:spPr>
-          <a:xfrm>
-            <a:off x="4572000" y="3246120"/>
-            <a:ext cx="3108960" cy="457200"/>
-          </a:xfrm>
-          <a:prstGeom prst="rect">
-            <a:avLst/>
-          </a:prstGeom>
-          <a:noFill/>
-        </p:spPr>
-        <p:txBody>
-          <a:bodyPr wrap="square">
-            <a:spAutoFit/>
-          </a:bodyPr>
-          <a:lstStyle/>
-          <a:p>
-            <a:pPr algn="l"/>
-            <a:r>
-              <a:rPr sz="2000" b="1">
-                <a:solidFill>
-                  <a:srgbClr val="0F2C4C"/>
-                </a:solidFill>
-                <a:latin typeface="Calibri"/>
-              </a:rPr>
-              <a:t>Pengguna jelas</a:t>
-            </a:r>
-          </a:p>
-        </p:txBody>
-      </p:sp>
-      <p:sp>
-        <p:nvSpPr>
-          <p:cNvPr id="15" name="TextBox 14"/>
-          <p:cNvSpPr txBox="1"/>
-          <p:nvPr/>
-        </p:nvSpPr>
-        <p:spPr>
-          <a:xfrm>
-            <a:off x="4572000" y="3886200"/>
-            <a:ext cx="3108960" cy="1097280"/>
-          </a:xfrm>
-          <a:prstGeom prst="rect">
-            <a:avLst/>
-          </a:prstGeom>
-          <a:noFill/>
-        </p:spPr>
-        <p:txBody>
-          <a:bodyPr wrap="square">
-            <a:spAutoFit/>
-          </a:bodyPr>
-          <a:lstStyle/>
-          <a:p>
-            <a:pPr algn="l"/>
-            <a:r>
-              <a:rPr sz="1600" b="0">
-                <a:solidFill>
-                  <a:srgbClr val="5A6570"/>
-                </a:solidFill>
-                <a:latin typeface="Calibri"/>
-              </a:rPr>
-              <a:t>Kita tahu siapa yang mengalami masalah itu</a:t>
-            </a:r>
-          </a:p>
-        </p:txBody>
-      </p:sp>
-      <p:sp>
-        <p:nvSpPr>
-          <p:cNvPr id="16" name="Rounded Rectangle 15"/>
-          <p:cNvSpPr/>
-          <p:nvPr/>
-        </p:nvSpPr>
-        <p:spPr>
-          <a:xfrm>
-            <a:off x="8138160" y="2926080"/>
+            <a:off x="8138160" y="3017520"/>
             <a:ext cx="3566160" cy="2286000"/>
           </a:xfrm>
           <a:prstGeom prst="roundRect">
@@ -11671,56 +11125,13 @@
       </p:sp>
       <p:sp>
         <p:nvSpPr>
-          <p:cNvPr id="17" name="Rectangle 16"/>
-          <p:cNvSpPr/>
-          <p:nvPr/>
-        </p:nvSpPr>
-        <p:spPr>
-          <a:xfrm>
-            <a:off x="8138160" y="2926080"/>
-            <a:ext cx="3566160" cy="109728"/>
-          </a:xfrm>
-          <a:prstGeom prst="rect">
-            <a:avLst/>
-          </a:prstGeom>
-          <a:solidFill>
-            <a:srgbClr val="1A6B6B"/>
-          </a:solidFill>
-          <a:ln>
-            <a:noFill/>
-          </a:ln>
-        </p:spPr>
-        <p:style>
-          <a:lnRef idx="1">
-            <a:schemeClr val="accent1"/>
-          </a:lnRef>
-          <a:fillRef idx="3">
-            <a:schemeClr val="accent1"/>
-          </a:fillRef>
-          <a:effectRef idx="2">
-            <a:schemeClr val="accent1"/>
-          </a:effectRef>
-          <a:fontRef idx="minor">
-            <a:schemeClr val="lt1"/>
-          </a:fontRef>
-        </p:style>
-        <p:txBody>
-          <a:bodyPr rtlCol="0" anchor="ctr"/>
-          <a:lstStyle/>
-          <a:p>
-            <a:pPr algn="ctr"/>
-          </a:p>
-        </p:txBody>
-      </p:sp>
-      <p:sp>
-        <p:nvSpPr>
-          <p:cNvPr id="18" name="TextBox 17"/>
-          <p:cNvSpPr txBox="1"/>
-          <p:nvPr/>
-        </p:nvSpPr>
-        <p:spPr>
-          <a:xfrm>
-            <a:off x="8366760" y="3246120"/>
+          <p:cNvPr id="15" name="TextBox 14"/>
+          <p:cNvSpPr txBox="1"/>
+          <p:nvPr/>
+        </p:nvSpPr>
+        <p:spPr>
+          <a:xfrm>
+            <a:off x="8366760" y="3291840"/>
             <a:ext cx="3108960" cy="457200"/>
           </a:xfrm>
           <a:prstGeom prst="rect">
@@ -11736,27 +11147,27 @@
           <a:p>
             <a:pPr algn="l"/>
             <a:r>
-              <a:rPr sz="2000" b="1">
+              <a:rPr sz="1800" b="1">
                 <a:solidFill>
                   <a:srgbClr val="0F2C4C"/>
                 </a:solidFill>
                 <a:latin typeface="Calibri"/>
               </a:rPr>
-              <a:t>Solusi bisa diuji</a:t>
-            </a:r>
-          </a:p>
-        </p:txBody>
-      </p:sp>
-      <p:sp>
-        <p:nvSpPr>
-          <p:cNvPr id="19" name="TextBox 18"/>
-          <p:cNvSpPr txBox="1"/>
-          <p:nvPr/>
-        </p:nvSpPr>
-        <p:spPr>
-          <a:xfrm>
-            <a:off x="8366760" y="3886200"/>
-            <a:ext cx="3108960" cy="1097280"/>
+              <a:t>Baru pikir solusi</a:t>
+            </a:r>
+          </a:p>
+        </p:txBody>
+      </p:sp>
+      <p:sp>
+        <p:nvSpPr>
+          <p:cNvPr id="16" name="TextBox 15"/>
+          <p:cNvSpPr txBox="1"/>
+          <p:nvPr/>
+        </p:nvSpPr>
+        <p:spPr>
+          <a:xfrm>
+            <a:off x="8366760" y="4023360"/>
+            <a:ext cx="3108960" cy="914400"/>
           </a:xfrm>
           <a:prstGeom prst="rect">
             <a:avLst/>
@@ -11777,14 +11188,14 @@
                 </a:solidFill>
                 <a:latin typeface="Calibri"/>
               </a:rPr>
-              <a:t>Bisa dicoba sederhana sebelum dibuat besar</a:t>
-            </a:r>
-          </a:p>
-        </p:txBody>
-      </p:sp>
-      <p:sp>
-        <p:nvSpPr>
-          <p:cNvPr id="20" name="TextBox 19"/>
+              <a:t>Baru kemudian pikir teknologi</a:t>
+            </a:r>
+          </a:p>
+        </p:txBody>
+      </p:sp>
+      <p:sp>
+        <p:nvSpPr>
+          <p:cNvPr id="17" name="TextBox 16"/>
           <p:cNvSpPr txBox="1"/>
           <p:nvPr/>
         </p:nvSpPr>
@@ -11812,14 +11223,14 @@
                 </a:solidFill>
                 <a:latin typeface="Calibri"/>
               </a:rPr>
-              <a:t>Technopreneurship · S1 Bisnis Digital Sem 3 · Sub-CPMK 1.1</a:t>
-            </a:r>
-          </a:p>
-        </p:txBody>
-      </p:sp>
-      <p:sp>
-        <p:nvSpPr>
-          <p:cNvPr id="21" name="TextBox 20"/>
+              <a:t>Technopreneurship · Bisnis Digital Sem 3 · Sub-CPMK 1.1</a:t>
+            </a:r>
+          </a:p>
+        </p:txBody>
+      </p:sp>
+      <p:sp>
+        <p:nvSpPr>
+          <p:cNvPr id="18" name="TextBox 17"/>
           <p:cNvSpPr txBox="1"/>
           <p:nvPr/>
         </p:nvSpPr>
@@ -11980,13 +11391,13 @@
           <a:p>
             <a:pPr algn="l"/>
             <a:r>
-              <a:rPr sz="2800" b="1">
+              <a:rPr sz="2600" b="1">
                 <a:solidFill>
                   <a:srgbClr val="0F2C4C"/>
                 </a:solidFill>
                 <a:latin typeface="Calibri"/>
               </a:rPr>
-              <a:t>1. Entrepreneur</a:t>
+              <a:t>Siapa itu entrepreneur?</a:t>
             </a:r>
           </a:p>
         </p:txBody>
@@ -12021,7 +11432,7 @@
                 </a:solidFill>
                 <a:latin typeface="Calibri"/>
               </a:rPr>
-              <a:t>Pelaku usaha yang menciptakan nilai</a:t>
+              <a:t>Orang yang berani mengubah keluhan menjadi peluang</a:t>
             </a:r>
           </a:p>
         </p:txBody>
@@ -12077,8 +11488,8 @@
         </p:nvSpPr>
         <p:spPr>
           <a:xfrm>
-            <a:off x="822960" y="1508760"/>
-            <a:ext cx="10515600" cy="1097280"/>
+            <a:off x="822960" y="1554480"/>
+            <a:ext cx="10515600" cy="1005840"/>
           </a:xfrm>
           <a:prstGeom prst="rect">
             <a:avLst/>
@@ -12093,13 +11504,13 @@
           <a:p>
             <a:pPr algn="l"/>
             <a:r>
-              <a:rPr sz="1900" b="0">
+              <a:rPr sz="1800" b="0">
                 <a:solidFill>
                   <a:srgbClr val="1C1C1C"/>
                 </a:solidFill>
                 <a:latin typeface="Calibri"/>
               </a:rPr>
-              <a:t>Entrepreneur adalah orang yang mengidentifikasi peluang, berani mengambil risiko wajar, mengelola sumber daya, dan menciptakan nilai melalui produk atau jasa.</a:t>
+              <a:t>Sederhananya: entrepreneur adalah orang yang melihat ada kebutuhan, lalu mencoba membuat solusi, mengelola apa yang dia punya, dan memberi manfaat bagi orang lain.</a:t>
             </a:r>
           </a:p>
         </p:txBody>
@@ -12113,7 +11524,7 @@
         <p:spPr>
           <a:xfrm>
             <a:off x="548640" y="3017520"/>
-            <a:ext cx="5486400" cy="1234440"/>
+            <a:ext cx="5486400" cy="1280160"/>
           </a:xfrm>
           <a:prstGeom prst="roundRect">
             <a:avLst/>
@@ -12177,7 +11588,7 @@
                 </a:solidFill>
                 <a:latin typeface="Calibri"/>
               </a:rPr>
-              <a:t>Melihat peluang</a:t>
+              <a:t>Dia lihat peluang</a:t>
             </a:r>
           </a:p>
         </p:txBody>
@@ -12190,7 +11601,7 @@
         </p:nvSpPr>
         <p:spPr>
           <a:xfrm>
-            <a:off x="777240" y="3566160"/>
+            <a:off x="777240" y="3611879"/>
             <a:ext cx="5029200" cy="502920"/>
           </a:xfrm>
           <a:prstGeom prst="rect">
@@ -12212,7 +11623,7 @@
                 </a:solidFill>
                 <a:latin typeface="Calibri"/>
               </a:rPr>
-              <a:t>Menemukan kebutuhan yang belum terlayani dengan baik</a:t>
+              <a:t>“Orang butuh ini, tapi belum ada yang bantu dengan baik.”</a:t>
             </a:r>
           </a:p>
         </p:txBody>
@@ -12226,7 +11637,7 @@
         <p:spPr>
           <a:xfrm>
             <a:off x="6309359" y="3017520"/>
-            <a:ext cx="5486400" cy="1234440"/>
+            <a:ext cx="5486400" cy="1280160"/>
           </a:xfrm>
           <a:prstGeom prst="roundRect">
             <a:avLst/>
@@ -12290,7 +11701,7 @@
                 </a:solidFill>
                 <a:latin typeface="Calibri"/>
               </a:rPr>
-              <a:t>Mengambil risiko wajar</a:t>
+              <a:t>Dia berani mencoba</a:t>
             </a:r>
           </a:p>
         </p:txBody>
@@ -12303,7 +11714,7 @@
         </p:nvSpPr>
         <p:spPr>
           <a:xfrm>
-            <a:off x="6537959" y="3566160"/>
+            <a:off x="6537959" y="3611879"/>
             <a:ext cx="5029200" cy="502920"/>
           </a:xfrm>
           <a:prstGeom prst="rect">
@@ -12325,7 +11736,7 @@
                 </a:solidFill>
                 <a:latin typeface="Calibri"/>
               </a:rPr>
-              <a:t>Berani mencoba, tetapi tetap memperhitungkan sumber daya</a:t>
+              <a:t>Tidak menunggu sempurna. Mulai dari yang mampu dilakukan.</a:t>
             </a:r>
           </a:p>
         </p:txBody>
@@ -12339,7 +11750,7 @@
         <p:spPr>
           <a:xfrm>
             <a:off x="548640" y="4434840"/>
-            <a:ext cx="5486400" cy="1234440"/>
+            <a:ext cx="5486400" cy="1280160"/>
           </a:xfrm>
           <a:prstGeom prst="roundRect">
             <a:avLst/>
@@ -12403,7 +11814,7 @@
                 </a:solidFill>
                 <a:latin typeface="Calibri"/>
               </a:rPr>
-              <a:t>Mengelola sumber daya</a:t>
+              <a:t>Dia atur sumber daya</a:t>
             </a:r>
           </a:p>
         </p:txBody>
@@ -12416,7 +11827,7 @@
         </p:nvSpPr>
         <p:spPr>
           <a:xfrm>
-            <a:off x="777240" y="4983479"/>
+            <a:off x="777240" y="5029200"/>
             <a:ext cx="5029200" cy="502920"/>
           </a:xfrm>
           <a:prstGeom prst="rect">
@@ -12438,7 +11849,7 @@
                 </a:solidFill>
                 <a:latin typeface="Calibri"/>
               </a:rPr>
-              <a:t>Orang, waktu, uang, dan jaringan dipakai secara terarah</a:t>
+              <a:t>Waktu, tenaga, uang kecil, teman—dipakai dengan cerdas.</a:t>
             </a:r>
           </a:p>
         </p:txBody>
@@ -12452,7 +11863,7 @@
         <p:spPr>
           <a:xfrm>
             <a:off x="6309359" y="4434840"/>
-            <a:ext cx="5486400" cy="1234440"/>
+            <a:ext cx="5486400" cy="1280160"/>
           </a:xfrm>
           <a:prstGeom prst="roundRect">
             <a:avLst/>
@@ -12516,7 +11927,7 @@
                 </a:solidFill>
                 <a:latin typeface="Calibri"/>
               </a:rPr>
-              <a:t>Menciptakan nilai</a:t>
+              <a:t>Dia ciptakan manfaat</a:t>
             </a:r>
           </a:p>
         </p:txBody>
@@ -12529,7 +11940,7 @@
         </p:nvSpPr>
         <p:spPr>
           <a:xfrm>
-            <a:off x="6537959" y="4983479"/>
+            <a:off x="6537959" y="5029200"/>
             <a:ext cx="5029200" cy="502920"/>
           </a:xfrm>
           <a:prstGeom prst="rect">
@@ -12551,7 +11962,7 @@
                 </a:solidFill>
                 <a:latin typeface="Calibri"/>
               </a:rPr>
-              <a:t>Hasilnya bermanfaat bagi pelanggan dan menghasilkan imbalan</a:t>
+              <a:t>Orang terbantu; dia juga mendapat imbalan yang wajar.</a:t>
             </a:r>
           </a:p>
         </p:txBody>
@@ -12586,7 +11997,7 @@
                 </a:solidFill>
                 <a:latin typeface="Calibri"/>
               </a:rPr>
-              <a:t>Technopreneurship · S1 Bisnis Digital Sem 3 · Sub-CPMK 1.1</a:t>
+              <a:t>Technopreneurship · Bisnis Digital Sem 3 · Sub-CPMK 1.1</a:t>
             </a:r>
           </a:p>
         </p:txBody>
@@ -12754,13 +12165,13 @@
           <a:p>
             <a:pPr algn="l"/>
             <a:r>
-              <a:rPr sz="2800" b="1">
+              <a:rPr sz="2600" b="1">
                 <a:solidFill>
                   <a:srgbClr val="0F2C4C"/>
                 </a:solidFill>
                 <a:latin typeface="Calibri"/>
               </a:rPr>
-              <a:t>Contoh entrepreneur (sederhana)</a:t>
+              <a:t>Contoh yang mudah dibayangkan</a:t>
             </a:r>
           </a:p>
         </p:txBody>
@@ -12795,7 +12206,7 @@
                 </a:solidFill>
                 <a:latin typeface="Calibri"/>
               </a:rPr>
-              <a:t>Teknologi boleh ada, tetapi belum harus jadi inti</a:t>
+              <a:t>Warung makan di dekat kos</a:t>
             </a:r>
           </a:p>
         </p:txBody>
@@ -12867,13 +12278,13 @@
           <a:p>
             <a:pPr algn="l"/>
             <a:r>
-              <a:rPr sz="2200" b="1">
+              <a:rPr sz="2000" b="1">
                 <a:solidFill>
                   <a:srgbClr val="0F2C4C"/>
                 </a:solidFill>
                 <a:latin typeface="Calibri"/>
               </a:rPr>
-              <a:t>Kasus warung makan</a:t>
+              <a:t>Cerita singkat</a:t>
             </a:r>
           </a:p>
         </p:txBody>
@@ -12886,7 +12297,7 @@
         </p:nvSpPr>
         <p:spPr>
           <a:xfrm>
-            <a:off x="868680" y="2286000"/>
+            <a:off x="868680" y="2194560"/>
             <a:ext cx="6583680" cy="3200400"/>
           </a:xfrm>
           <a:prstGeom prst="rect">
@@ -12912,7 +12323,7 @@
                 </a:solidFill>
                 <a:latin typeface="Calibri"/>
               </a:rPr>
-              <a:t>• Masalah: tetangga sering minta antar karena hujan/sibuk</a:t>
+              <a:t>Ibu warung sering mendengar: “Bu, bisa diantar? Hujan deras.”</a:t>
             </a:r>
           </a:p>
           <a:p>
@@ -12928,7 +12339,7 @@
                 </a:solidFill>
                 <a:latin typeface="Calibri"/>
               </a:rPr>
-              <a:t>• Tindakan: pemilik warung menambah layanan antar</a:t>
+              <a:t>Dia lalu menawarkan antar untuk tetangga sekitar.</a:t>
             </a:r>
           </a:p>
           <a:p>
@@ -12944,7 +12355,7 @@
                 </a:solidFill>
                 <a:latin typeface="Calibri"/>
               </a:rPr>
-              <a:t>• Nilai: pelanggan lebih mudah makan, omzet naik</a:t>
+              <a:t>Pelanggan lega. Omzet ibu naik sedikit.</a:t>
             </a:r>
           </a:p>
           <a:p>
@@ -12960,7 +12371,7 @@
                 </a:solidFill>
                 <a:latin typeface="Calibri"/>
               </a:rPr>
-              <a:t>• Teknologi: bisa pakai WhatsApp, tetapi inti usahanya tetap makanan &amp; layanan</a:t>
+              <a:t>Dia boleh pakai WhatsApp untuk terima pesanan.</a:t>
             </a:r>
           </a:p>
           <a:p>
@@ -12992,7 +12403,23 @@
                 </a:solidFill>
                 <a:latin typeface="Calibri"/>
               </a:rPr>
-              <a:t>Kesimpulan: ini entrepreneur. Digitalisasi ringan belum otomatis menjadikan seseorang technopreneur.</a:t>
+              <a:t>Apakah dia entrepreneur? Ya.</a:t>
+            </a:r>
+          </a:p>
+          <a:p>
+            <a:pPr algn="l">
+              <a:spcAft>
+                <a:spcPts val="600"/>
+              </a:spcAft>
+            </a:pPr>
+            <a:r>
+              <a:rPr sz="1600" b="0">
+                <a:solidFill>
+                  <a:srgbClr val="1C1C1C"/>
+                </a:solidFill>
+                <a:latin typeface="Calibri"/>
+              </a:rPr>
+              <a:t>Apakah otomatis technopreneur? Belum tentu—karena inti usahanya tetap masakan dan layanan antar, bukan teknologi.</a:t>
             </a:r>
           </a:p>
         </p:txBody>
@@ -13048,7 +12475,7 @@
         </p:nvSpPr>
         <p:spPr>
           <a:xfrm>
-            <a:off x="8229600" y="2011680"/>
+            <a:off x="8229600" y="2103120"/>
             <a:ext cx="3108960" cy="457200"/>
           </a:xfrm>
           <a:prstGeom prst="rect">
@@ -13064,13 +12491,13 @@
           <a:p>
             <a:pPr algn="l"/>
             <a:r>
-              <a:rPr sz="1800" b="1">
+              <a:rPr sz="1600" b="1">
                 <a:solidFill>
                   <a:srgbClr val="D97B2A"/>
                 </a:solidFill>
                 <a:latin typeface="Calibri"/>
               </a:rPr>
-              <a:t>Inti pesan</a:t>
+              <a:t>Yang perlu diingat</a:t>
             </a:r>
           </a:p>
         </p:txBody>
@@ -13083,8 +12510,8 @@
         </p:nvSpPr>
         <p:spPr>
           <a:xfrm>
-            <a:off x="8229600" y="2651760"/>
-            <a:ext cx="3108960" cy="2560320"/>
+            <a:off x="8229600" y="2834640"/>
+            <a:ext cx="3108960" cy="2286000"/>
           </a:xfrm>
           <a:prstGeom prst="rect">
             <a:avLst/>
@@ -13099,13 +12526,13 @@
           <a:p>
             <a:pPr algn="l"/>
             <a:r>
-              <a:rPr sz="1700" b="0">
+              <a:rPr sz="1600" b="0">
                 <a:solidFill>
                   <a:srgbClr val="FFFFFF"/>
                 </a:solidFill>
                 <a:latin typeface="Calibri"/>
               </a:rPr>
-              <a:t>Entrepreneur fokus pada peluang dan nilai. Teknologi bersifat pilihan pendukung, bukan syarat mutlak.</a:t>
+              <a:t>Pakai HP untuk jualan belum tentu berarti Anda sudah jadi technopreneur. Yang penting: apa yang benar-benar menjadi jantung usaha Anda?</a:t>
             </a:r>
           </a:p>
         </p:txBody>
@@ -13140,7 +12567,7 @@
                 </a:solidFill>
                 <a:latin typeface="Calibri"/>
               </a:rPr>
-              <a:t>Technopreneurship · S1 Bisnis Digital Sem 3 · Sub-CPMK 1.1</a:t>
+              <a:t>Technopreneurship · Bisnis Digital Sem 3 · Sub-CPMK 1.1</a:t>
             </a:r>
           </a:p>
         </p:txBody>
@@ -13308,13 +12735,13 @@
           <a:p>
             <a:pPr algn="l"/>
             <a:r>
-              <a:rPr sz="2800" b="1">
+              <a:rPr sz="2600" b="1">
                 <a:solidFill>
                   <a:srgbClr val="0F2C4C"/>
                 </a:solidFill>
                 <a:latin typeface="Calibri"/>
               </a:rPr>
-              <a:t>2. Technopreneur</a:t>
+              <a:t>Lalu, siapa technopreneur?</a:t>
             </a:r>
           </a:p>
         </p:txBody>
@@ -13349,7 +12776,7 @@
                 </a:solidFill>
                 <a:latin typeface="Calibri"/>
               </a:rPr>
-              <a:t>Entrepreneur yang menjadikan teknologi sebagai inti nilai</a:t>
+              <a:t>Entrepreneur yang menaruh teknologi di pusat solusinya</a:t>
             </a:r>
           </a:p>
         </p:txBody>
@@ -13363,7 +12790,7 @@
         <p:spPr>
           <a:xfrm>
             <a:off x="548640" y="1325880"/>
-            <a:ext cx="11064240" cy="1554480"/>
+            <a:ext cx="11064240" cy="1371600"/>
           </a:xfrm>
           <a:prstGeom prst="roundRect">
             <a:avLst/>
@@ -13406,7 +12833,7 @@
         <p:spPr>
           <a:xfrm>
             <a:off x="822960" y="1554480"/>
-            <a:ext cx="10515600" cy="1097280"/>
+            <a:ext cx="10515600" cy="914400"/>
           </a:xfrm>
           <a:prstGeom prst="rect">
             <a:avLst/>
@@ -13427,7 +12854,7 @@
                 </a:solidFill>
                 <a:latin typeface="Calibri"/>
               </a:rPr>
-              <a:t>Technopreneur adalah entrepreneur yang memakai teknologi sebagai unsur utama dalam menciptakan produk, layanan, proses, atau model bisnis—bukan sekadar “pakai HP untuk jualan”.</a:t>
+              <a:t>Kalau entrepreneur fokus “menolong lewat usaha”, technopreneur fokus “menolong lewat usaha yang jantungnya teknologi”.</a:t>
             </a:r>
           </a:p>
         </p:txBody>
@@ -13440,8 +12867,8 @@
         </p:nvSpPr>
         <p:spPr>
           <a:xfrm>
-            <a:off x="548640" y="3200400"/>
-            <a:ext cx="5394960" cy="2468880"/>
+            <a:off x="548640" y="3017520"/>
+            <a:ext cx="5394960" cy="2651760"/>
           </a:xfrm>
           <a:prstGeom prst="roundRect">
             <a:avLst/>
@@ -13483,7 +12910,7 @@
         </p:nvSpPr>
         <p:spPr>
           <a:xfrm>
-            <a:off x="822960" y="3429000"/>
+            <a:off x="822960" y="3246120"/>
             <a:ext cx="4846320" cy="365760"/>
           </a:xfrm>
           <a:prstGeom prst="rect">
@@ -13499,13 +12926,13 @@
           <a:p>
             <a:pPr algn="l"/>
             <a:r>
-              <a:rPr sz="1800" b="1">
+              <a:rPr sz="1700" b="1">
                 <a:solidFill>
                   <a:srgbClr val="B04A2F"/>
                 </a:solidFill>
                 <a:latin typeface="Calibri"/>
               </a:rPr>
-              <a:t>Bukan technopreneur jika…</a:t>
+              <a:t>Belum termasuk, kalau…</a:t>
             </a:r>
           </a:p>
         </p:txBody>
@@ -13518,8 +12945,8 @@
         </p:nvSpPr>
         <p:spPr>
           <a:xfrm>
-            <a:off x="822960" y="3977639"/>
-            <a:ext cx="4846320" cy="1463040"/>
+            <a:off x="822960" y="3794760"/>
+            <a:ext cx="4846320" cy="1554480"/>
           </a:xfrm>
           <a:prstGeom prst="rect">
             <a:avLst/>
@@ -13544,7 +12971,7 @@
                 </a:solidFill>
                 <a:latin typeface="Calibri"/>
               </a:rPr>
-              <a:t>• Hanya memindahkan katalog ke WhatsApp</a:t>
+              <a:t>• Hanya pindah daftar menu ke WhatsApp</a:t>
             </a:r>
           </a:p>
           <a:p>
@@ -13560,7 +12987,7 @@
                 </a:solidFill>
                 <a:latin typeface="Calibri"/>
               </a:rPr>
-              <a:t>• Hanya punya akun marketplace tanpa inovasi</a:t>
+              <a:t>• Hanya buka akun marketplace tanpa inovasi</a:t>
             </a:r>
           </a:p>
           <a:p>
@@ -13576,7 +13003,7 @@
                 </a:solidFill>
                 <a:latin typeface="Calibri"/>
               </a:rPr>
-              <a:t>• Teknologi hanya alat komunikasi biasa</a:t>
+              <a:t>• Teknologi cuma alat chat biasa</a:t>
             </a:r>
           </a:p>
         </p:txBody>
@@ -13589,8 +13016,8 @@
         </p:nvSpPr>
         <p:spPr>
           <a:xfrm>
-            <a:off x="6217920" y="3200400"/>
-            <a:ext cx="5394960" cy="2468880"/>
+            <a:off x="6217920" y="3017520"/>
+            <a:ext cx="5394960" cy="2651760"/>
           </a:xfrm>
           <a:prstGeom prst="roundRect">
             <a:avLst/>
@@ -13632,7 +13059,7 @@
         </p:nvSpPr>
         <p:spPr>
           <a:xfrm>
-            <a:off x="6492240" y="3429000"/>
+            <a:off x="6492240" y="3246120"/>
             <a:ext cx="4846320" cy="365760"/>
           </a:xfrm>
           <a:prstGeom prst="rect">
@@ -13648,13 +13075,13 @@
           <a:p>
             <a:pPr algn="l"/>
             <a:r>
-              <a:rPr sz="1800" b="1">
+              <a:rPr sz="1600" b="1">
                 <a:solidFill>
                   <a:srgbClr val="2F7D4F"/>
                 </a:solidFill>
                 <a:latin typeface="Calibri"/>
               </a:rPr>
-              <a:t>Termasuk technopreneur jika…</a:t>
+              <a:t>Sudah mengarah technopreneur, kalau…</a:t>
             </a:r>
           </a:p>
         </p:txBody>
@@ -13667,8 +13094,8 @@
         </p:nvSpPr>
         <p:spPr>
           <a:xfrm>
-            <a:off x="6492240" y="3977639"/>
-            <a:ext cx="4846320" cy="1463040"/>
+            <a:off x="6492240" y="3794760"/>
+            <a:ext cx="4846320" cy="1554480"/>
           </a:xfrm>
           <a:prstGeom prst="rect">
             <a:avLst/>
@@ -13693,7 +13120,7 @@
                 </a:solidFill>
                 <a:latin typeface="Calibri"/>
               </a:rPr>
-              <a:t>• Membangun app antrian kampus</a:t>
+              <a:t>• Buat sistem antrean kantin biar lebih adil</a:t>
             </a:r>
           </a:p>
           <a:p>
@@ -13709,7 +13136,7 @@
                 </a:solidFill>
                 <a:latin typeface="Calibri"/>
               </a:rPr>
-              <a:t>• Membuat sistem kasir cloud untuk UMKM</a:t>
+              <a:t>• Buat pencatatan kasir yang rapi di cloud</a:t>
             </a:r>
           </a:p>
           <a:p>
@@ -13725,7 +13152,7 @@
                 </a:solidFill>
                 <a:latin typeface="Calibri"/>
               </a:rPr>
-              <a:t>• Teknologi menjadi inti solusi yang ditawarkan</a:t>
+              <a:t>• Tanpa teknologi itu, solusinya tidak jalan</a:t>
             </a:r>
           </a:p>
         </p:txBody>
@@ -13760,7 +13187,7 @@
                 </a:solidFill>
                 <a:latin typeface="Calibri"/>
               </a:rPr>
-              <a:t>Technopreneurship · S1 Bisnis Digital Sem 3 · Sub-CPMK 1.1</a:t>
+              <a:t>Technopreneurship · Bisnis Digital Sem 3 · Sub-CPMK 1.1</a:t>
             </a:r>
           </a:p>
         </p:txBody>
@@ -13928,13 +13355,13 @@
           <a:p>
             <a:pPr algn="l"/>
             <a:r>
-              <a:rPr sz="2800" b="1">
+              <a:rPr sz="2600" b="1">
                 <a:solidFill>
                   <a:srgbClr val="0F2C4C"/>
                 </a:solidFill>
                 <a:latin typeface="Calibri"/>
               </a:rPr>
-              <a:t>Contoh technopreneur</a:t>
+              <a:t>Contoh technopreneur yang dekat dengan kampus</a:t>
             </a:r>
           </a:p>
         </p:txBody>
@@ -13969,7 +13396,7 @@
                 </a:solidFill>
                 <a:latin typeface="Calibri"/>
               </a:rPr>
-              <a:t>Teknologi = tulang punggung solusi</a:t>
+              <a:t>Teknologi bukan hiasan—tanpa itu, solusi gugur</a:t>
             </a:r>
           </a:p>
         </p:txBody>
@@ -14026,7 +13453,7 @@
         <p:spPr>
           <a:xfrm>
             <a:off x="548640" y="1463040"/>
-            <a:ext cx="3611880" cy="822960"/>
+            <a:ext cx="3611880" cy="914400"/>
           </a:xfrm>
           <a:prstGeom prst="rect">
             <a:avLst/>
@@ -14069,7 +13496,7 @@
         <p:spPr>
           <a:xfrm>
             <a:off x="731520" y="1645920"/>
-            <a:ext cx="3200400" cy="502920"/>
+            <a:ext cx="3200400" cy="548640"/>
           </a:xfrm>
           <a:prstGeom prst="rect">
             <a:avLst/>
@@ -14084,13 +13511,13 @@
           <a:p>
             <a:pPr algn="l"/>
             <a:r>
-              <a:rPr sz="1800" b="1">
+              <a:rPr sz="1600" b="1">
                 <a:solidFill>
                   <a:srgbClr val="FFFFFF"/>
                 </a:solidFill>
                 <a:latin typeface="Calibri"/>
               </a:rPr>
-              <a:t>App antrian kampus</a:t>
+              <a:t>Sistem antrean kantin</a:t>
             </a:r>
           </a:p>
         </p:txBody>
@@ -14103,7 +13530,7 @@
         </p:nvSpPr>
         <p:spPr>
           <a:xfrm>
-            <a:off x="777240" y="2560320"/>
+            <a:off x="777240" y="2651760"/>
             <a:ext cx="3154680" cy="2560320"/>
           </a:xfrm>
           <a:prstGeom prst="rect">
@@ -14119,13 +13546,13 @@
           <a:p>
             <a:pPr algn="l"/>
             <a:r>
-              <a:rPr sz="1600" b="0">
+              <a:rPr sz="1500" b="0">
                 <a:solidFill>
                   <a:srgbClr val="1C1C1C"/>
                 </a:solidFill>
                 <a:latin typeface="Calibri"/>
               </a:rPr>
-              <a:t>Masalah antre lama di kantin/administrasi diselesaikan dengan sistem digital antrian.</a:t>
+              <a:t>Mahasiswa ambil nomor lewat HP. Antri lebih tertib. Intinya: sistem digitalnya.</a:t>
             </a:r>
           </a:p>
         </p:txBody>
@@ -14182,7 +13609,7 @@
         <p:spPr>
           <a:xfrm>
             <a:off x="4343400" y="1463040"/>
-            <a:ext cx="3611880" cy="822960"/>
+            <a:ext cx="3611880" cy="914400"/>
           </a:xfrm>
           <a:prstGeom prst="rect">
             <a:avLst/>
@@ -14225,7 +13652,7 @@
         <p:spPr>
           <a:xfrm>
             <a:off x="4526280" y="1645920"/>
-            <a:ext cx="3200400" cy="502920"/>
+            <a:ext cx="3200400" cy="548640"/>
           </a:xfrm>
           <a:prstGeom prst="rect">
             <a:avLst/>
@@ -14240,13 +13667,13 @@
           <a:p>
             <a:pPr algn="l"/>
             <a:r>
-              <a:rPr sz="1800" b="1">
+              <a:rPr sz="1600" b="1">
                 <a:solidFill>
                   <a:srgbClr val="FFFFFF"/>
                 </a:solidFill>
                 <a:latin typeface="Calibri"/>
               </a:rPr>
-              <a:t>Kasir cloud UMKM</a:t>
+              <a:t>Kasir sederhana untuk UMKM</a:t>
             </a:r>
           </a:p>
         </p:txBody>
@@ -14259,7 +13686,7 @@
         </p:nvSpPr>
         <p:spPr>
           <a:xfrm>
-            <a:off x="4572000" y="2560320"/>
+            <a:off x="4572000" y="2651760"/>
             <a:ext cx="3154680" cy="2560320"/>
           </a:xfrm>
           <a:prstGeom prst="rect">
@@ -14275,13 +13702,13 @@
           <a:p>
             <a:pPr algn="l"/>
             <a:r>
-              <a:rPr sz="1600" b="0">
+              <a:rPr sz="1500" b="0">
                 <a:solidFill>
                   <a:srgbClr val="1C1C1C"/>
                 </a:solidFill>
                 <a:latin typeface="Calibri"/>
               </a:rPr>
-              <a:t>Pencatatan stok &amp; penjualan digabung dalam sistem yang bisa diakses kapan saja.</a:t>
+              <a:t>Pemilik toko catat stok &amp; penjualan di satu tempat yang bisa dibuka kapan saja.</a:t>
             </a:r>
           </a:p>
         </p:txBody>
@@ -14338,7 +13765,7 @@
         <p:spPr>
           <a:xfrm>
             <a:off x="8138160" y="1463040"/>
-            <a:ext cx="3611880" cy="822960"/>
+            <a:ext cx="3611880" cy="914400"/>
           </a:xfrm>
           <a:prstGeom prst="rect">
             <a:avLst/>
@@ -14381,7 +13808,7 @@
         <p:spPr>
           <a:xfrm>
             <a:off x="8321040" y="1645920"/>
-            <a:ext cx="3200400" cy="502920"/>
+            <a:ext cx="3200400" cy="548640"/>
           </a:xfrm>
           <a:prstGeom prst="rect">
             <a:avLst/>
@@ -14396,13 +13823,13 @@
           <a:p>
             <a:pPr algn="l"/>
             <a:r>
-              <a:rPr sz="1800" b="1">
+              <a:rPr sz="1600" b="1">
                 <a:solidFill>
                   <a:srgbClr val="FFFFFF"/>
                 </a:solidFill>
                 <a:latin typeface="Calibri"/>
               </a:rPr>
-              <a:t>Sensor + langganan</a:t>
+              <a:t>Pantau tanaman + layanan</a:t>
             </a:r>
           </a:p>
         </p:txBody>
@@ -14415,7 +13842,7 @@
         </p:nvSpPr>
         <p:spPr>
           <a:xfrm>
-            <a:off x="8366760" y="2560320"/>
+            <a:off x="8366760" y="2651760"/>
             <a:ext cx="3154680" cy="2560320"/>
           </a:xfrm>
           <a:prstGeom prst="rect">
@@ -14431,13 +13858,13 @@
           <a:p>
             <a:pPr algn="l"/>
             <a:r>
-              <a:rPr sz="1600" b="0">
+              <a:rPr sz="1500" b="0">
                 <a:solidFill>
                   <a:srgbClr val="1C1C1C"/>
                 </a:solidFill>
                 <a:latin typeface="Calibri"/>
               </a:rPr>
-              <a:t>Monitoring tanaman/alat memakai IoT + model langganan data/layanan.</a:t>
+              <a:t>Alat sensor kirim info ke HP petani/penyewa. Tanpa sensor, layanan tidak ada.</a:t>
             </a:r>
           </a:p>
         </p:txBody>
@@ -14472,7 +13899,7 @@
                 </a:solidFill>
                 <a:latin typeface="Calibri"/>
               </a:rPr>
-              <a:t>Technopreneurship · S1 Bisnis Digital Sem 3 · Sub-CPMK 1.1</a:t>
+              <a:t>Technopreneurship · Bisnis Digital Sem 3 · Sub-CPMK 1.1</a:t>
             </a:r>
           </a:p>
         </p:txBody>
@@ -14640,13 +14067,13 @@
           <a:p>
             <a:pPr algn="l"/>
             <a:r>
-              <a:rPr sz="2800" b="1">
+              <a:rPr sz="2600" b="1">
                 <a:solidFill>
                   <a:srgbClr val="0F2C4C"/>
                 </a:solidFill>
                 <a:latin typeface="Calibri"/>
               </a:rPr>
-              <a:t>3. Bisnis Digital</a:t>
+              <a:t>Apa itu bisnis digital?</a:t>
             </a:r>
           </a:p>
         </p:txBody>
@@ -14681,7 +14108,7 @@
                 </a:solidFill>
                 <a:latin typeface="Calibri"/>
               </a:rPr>
-              <a:t>Usaha yang menghasilkan nilai melalui ruang digital</a:t>
+              <a:t>Usaha yang hidup utamanya di ruang online</a:t>
             </a:r>
           </a:p>
         </p:txBody>
@@ -14759,7 +14186,7 @@
                 </a:solidFill>
                 <a:latin typeface="Calibri"/>
               </a:rPr>
-              <a:t>Bisnis digital adalah kegiatan usaha yang menciptakan nilai melalui kanal, produk, atau proses digital: platform, e-commerce, konten, SaaS, marketplace, dan sejenisnya.</a:t>
+              <a:t>Bisnis digital berarti pelanggan mengenal, membeli, memakai, atau membayar Anda lewat jalur digital: aplikasi, web, media sosial, marketplace, dan sejenisnya.</a:t>
             </a:r>
           </a:p>
         </p:txBody>
@@ -14815,8 +14242,8 @@
         </p:nvSpPr>
         <p:spPr>
           <a:xfrm>
-            <a:off x="731520" y="3291840"/>
-            <a:ext cx="2377440" cy="731520"/>
+            <a:off x="685800" y="3246120"/>
+            <a:ext cx="2468880" cy="640080"/>
           </a:xfrm>
           <a:prstGeom prst="rect">
             <a:avLst/>
@@ -14831,13 +14258,13 @@
           <a:p>
             <a:pPr algn="l"/>
             <a:r>
-              <a:rPr sz="1600" b="1">
+              <a:rPr sz="1500" b="1">
                 <a:solidFill>
                   <a:srgbClr val="0F2C4C"/>
                 </a:solidFill>
                 <a:latin typeface="Calibri"/>
               </a:rPr>
-              <a:t>Pelanggan online</a:t>
+              <a:t>Bertemu pelanggan online</a:t>
             </a:r>
           </a:p>
         </p:txBody>
@@ -14850,8 +14277,8 @@
         </p:nvSpPr>
         <p:spPr>
           <a:xfrm>
-            <a:off x="731520" y="4114800"/>
-            <a:ext cx="2377440" cy="1097280"/>
+            <a:off x="685800" y="4023360"/>
+            <a:ext cx="2468880" cy="1097280"/>
           </a:xfrm>
           <a:prstGeom prst="rect">
             <a:avLst/>
@@ -14872,7 +14299,7 @@
                 </a:solidFill>
                 <a:latin typeface="Calibri"/>
               </a:rPr>
-              <a:t>Interaksi &amp; transaksi lewat kanal digital</a:t>
+              <a:t>Chat, konten, toko online, aplikasi</a:t>
             </a:r>
           </a:p>
         </p:txBody>
@@ -14928,8 +14355,8 @@
         </p:nvSpPr>
         <p:spPr>
           <a:xfrm>
-            <a:off x="3611880" y="3291840"/>
-            <a:ext cx="2377440" cy="731520"/>
+            <a:off x="3566160" y="3246120"/>
+            <a:ext cx="2468880" cy="640080"/>
           </a:xfrm>
           <a:prstGeom prst="rect">
             <a:avLst/>
@@ -14944,13 +14371,13 @@
           <a:p>
             <a:pPr algn="l"/>
             <a:r>
-              <a:rPr sz="1600" b="1">
+              <a:rPr sz="1500" b="1">
                 <a:solidFill>
                   <a:srgbClr val="0F2C4C"/>
                 </a:solidFill>
                 <a:latin typeface="Calibri"/>
               </a:rPr>
-              <a:t>Data &amp; insight</a:t>
+              <a:t>Belajar dari perilaku</a:t>
             </a:r>
           </a:p>
         </p:txBody>
@@ -14963,8 +14390,8 @@
         </p:nvSpPr>
         <p:spPr>
           <a:xfrm>
-            <a:off x="3611880" y="4114800"/>
-            <a:ext cx="2377440" cy="1097280"/>
+            <a:off x="3566160" y="4023360"/>
+            <a:ext cx="2468880" cy="1097280"/>
           </a:xfrm>
           <a:prstGeom prst="rect">
             <a:avLst/>
@@ -14985,7 +14412,7 @@
                 </a:solidFill>
                 <a:latin typeface="Calibri"/>
               </a:rPr>
-              <a:t>Keputusan dibantu data perilaku pengguna</a:t>
+              <a:t>Apa yang sering diklik/dibeli?</a:t>
             </a:r>
           </a:p>
         </p:txBody>
@@ -15041,8 +14468,8 @@
         </p:nvSpPr>
         <p:spPr>
           <a:xfrm>
-            <a:off x="6492240" y="3291840"/>
-            <a:ext cx="2377440" cy="731520"/>
+            <a:off x="6446520" y="3246120"/>
+            <a:ext cx="2468880" cy="640080"/>
           </a:xfrm>
           <a:prstGeom prst="rect">
             <a:avLst/>
@@ -15057,13 +14484,13 @@
           <a:p>
             <a:pPr algn="l"/>
             <a:r>
-              <a:rPr sz="1600" b="1">
+              <a:rPr sz="1500" b="1">
                 <a:solidFill>
                   <a:srgbClr val="0F2C4C"/>
                 </a:solidFill>
                 <a:latin typeface="Calibri"/>
               </a:rPr>
-              <a:t>Kanal digital</a:t>
+              <a:t>Saluran digital</a:t>
             </a:r>
           </a:p>
         </p:txBody>
@@ -15076,8 +14503,8 @@
         </p:nvSpPr>
         <p:spPr>
           <a:xfrm>
-            <a:off x="6492240" y="4114800"/>
-            <a:ext cx="2377440" cy="1097280"/>
+            <a:off x="6446520" y="4023360"/>
+            <a:ext cx="2468880" cy="1097280"/>
           </a:xfrm>
           <a:prstGeom prst="rect">
             <a:avLst/>
@@ -15098,7 +14525,7 @@
                 </a:solidFill>
                 <a:latin typeface="Calibri"/>
               </a:rPr>
-              <a:t>Media sosial, web, app, marketplace</a:t>
+              <a:t>IG, TikTok, web, marketplace</a:t>
             </a:r>
           </a:p>
         </p:txBody>
@@ -15154,8 +14581,8 @@
         </p:nvSpPr>
         <p:spPr>
           <a:xfrm>
-            <a:off x="9372599" y="3291840"/>
-            <a:ext cx="2377440" cy="731520"/>
+            <a:off x="9326880" y="3246120"/>
+            <a:ext cx="2468880" cy="640080"/>
           </a:xfrm>
           <a:prstGeom prst="rect">
             <a:avLst/>
@@ -15170,13 +14597,13 @@
           <a:p>
             <a:pPr algn="l"/>
             <a:r>
-              <a:rPr sz="1600" b="1">
+              <a:rPr sz="1500" b="1">
                 <a:solidFill>
                   <a:srgbClr val="0F2C4C"/>
                 </a:solidFill>
                 <a:latin typeface="Calibri"/>
               </a:rPr>
-              <a:t>Monetisasi digital</a:t>
+              <a:t>Cara dapat uang</a:t>
             </a:r>
           </a:p>
         </p:txBody>
@@ -15189,8 +14616,8 @@
         </p:nvSpPr>
         <p:spPr>
           <a:xfrm>
-            <a:off x="9372599" y="4114800"/>
-            <a:ext cx="2377440" cy="1097280"/>
+            <a:off x="9326880" y="4023360"/>
+            <a:ext cx="2468880" cy="1097280"/>
           </a:xfrm>
           <a:prstGeom prst="rect">
             <a:avLst/>
@@ -15211,7 +14638,7 @@
                 </a:solidFill>
                 <a:latin typeface="Calibri"/>
               </a:rPr>
-              <a:t>Langganan, komisi, iklan, transaksi online</a:t>
+              <a:t>Transfer, QRIS, langganan, komisi</a:t>
             </a:r>
           </a:p>
         </p:txBody>
@@ -15246,7 +14673,7 @@
                 </a:solidFill>
                 <a:latin typeface="Calibri"/>
               </a:rPr>
-              <a:t>Technopreneurship · S1 Bisnis Digital Sem 3 · Sub-CPMK 1.1</a:t>
+              <a:t>Technopreneurship · Bisnis Digital Sem 3 · Sub-CPMK 1.1</a:t>
             </a:r>
           </a:p>
         </p:txBody>

</xml_diff>